<commit_message>
Update sample responses and add detailed explanations
Expanded and corrected entries in gpt-5_cove_se_outputs_gpt-5_sample_responses.csv, providing more detailed explanations, clarifications, and context for various questions. This improves the accuracy and informativeness of the sample responses for chain-of-verification tasks.
</commit_message>
<xml_diff>
--- a/slides/20251210.pptx
+++ b/slides/20251210.pptx
@@ -7,10 +7,12 @@
   <p:sldIdLst>
     <p:sldId id="260" r:id="rId2"/>
     <p:sldId id="261" r:id="rId3"/>
-    <p:sldId id="257" r:id="rId4"/>
-    <p:sldId id="264" r:id="rId5"/>
-    <p:sldId id="263" r:id="rId6"/>
-    <p:sldId id="259" r:id="rId7"/>
+    <p:sldId id="265" r:id="rId4"/>
+    <p:sldId id="266" r:id="rId5"/>
+    <p:sldId id="257" r:id="rId6"/>
+    <p:sldId id="264" r:id="rId7"/>
+    <p:sldId id="263" r:id="rId8"/>
+    <p:sldId id="259" r:id="rId9"/>
   </p:sldIdLst>
   <p:sldSz cx="12192000" cy="6858000"/>
   <p:notesSz cx="6858000" cy="9144000"/>
@@ -264,7 +266,7 @@
           <a:p>
             <a:fld id="{3F567BA6-CBC2-4FF0-810E-3ED1BF2C4381}" type="datetimeFigureOut">
               <a:rPr lang="zh-CN" altLang="en-US" smtClean="0"/>
-              <a:t>2025/12/4</a:t>
+              <a:t>2025/12/11</a:t>
             </a:fld>
             <a:endParaRPr lang="zh-CN" altLang="en-US"/>
           </a:p>
@@ -462,7 +464,7 @@
           <a:p>
             <a:fld id="{3F567BA6-CBC2-4FF0-810E-3ED1BF2C4381}" type="datetimeFigureOut">
               <a:rPr lang="zh-CN" altLang="en-US" smtClean="0"/>
-              <a:t>2025/12/4</a:t>
+              <a:t>2025/12/11</a:t>
             </a:fld>
             <a:endParaRPr lang="zh-CN" altLang="en-US"/>
           </a:p>
@@ -670,7 +672,7 @@
           <a:p>
             <a:fld id="{3F567BA6-CBC2-4FF0-810E-3ED1BF2C4381}" type="datetimeFigureOut">
               <a:rPr lang="zh-CN" altLang="en-US" smtClean="0"/>
-              <a:t>2025/12/4</a:t>
+              <a:t>2025/12/11</a:t>
             </a:fld>
             <a:endParaRPr lang="zh-CN" altLang="en-US"/>
           </a:p>
@@ -868,7 +870,7 @@
           <a:p>
             <a:fld id="{3F567BA6-CBC2-4FF0-810E-3ED1BF2C4381}" type="datetimeFigureOut">
               <a:rPr lang="zh-CN" altLang="en-US" smtClean="0"/>
-              <a:t>2025/12/4</a:t>
+              <a:t>2025/12/11</a:t>
             </a:fld>
             <a:endParaRPr lang="zh-CN" altLang="en-US"/>
           </a:p>
@@ -1143,7 +1145,7 @@
           <a:p>
             <a:fld id="{3F567BA6-CBC2-4FF0-810E-3ED1BF2C4381}" type="datetimeFigureOut">
               <a:rPr lang="zh-CN" altLang="en-US" smtClean="0"/>
-              <a:t>2025/12/4</a:t>
+              <a:t>2025/12/11</a:t>
             </a:fld>
             <a:endParaRPr lang="zh-CN" altLang="en-US"/>
           </a:p>
@@ -1408,7 +1410,7 @@
           <a:p>
             <a:fld id="{3F567BA6-CBC2-4FF0-810E-3ED1BF2C4381}" type="datetimeFigureOut">
               <a:rPr lang="zh-CN" altLang="en-US" smtClean="0"/>
-              <a:t>2025/12/4</a:t>
+              <a:t>2025/12/11</a:t>
             </a:fld>
             <a:endParaRPr lang="zh-CN" altLang="en-US"/>
           </a:p>
@@ -1820,7 +1822,7 @@
           <a:p>
             <a:fld id="{3F567BA6-CBC2-4FF0-810E-3ED1BF2C4381}" type="datetimeFigureOut">
               <a:rPr lang="zh-CN" altLang="en-US" smtClean="0"/>
-              <a:t>2025/12/4</a:t>
+              <a:t>2025/12/11</a:t>
             </a:fld>
             <a:endParaRPr lang="zh-CN" altLang="en-US"/>
           </a:p>
@@ -1961,7 +1963,7 @@
           <a:p>
             <a:fld id="{3F567BA6-CBC2-4FF0-810E-3ED1BF2C4381}" type="datetimeFigureOut">
               <a:rPr lang="zh-CN" altLang="en-US" smtClean="0"/>
-              <a:t>2025/12/4</a:t>
+              <a:t>2025/12/11</a:t>
             </a:fld>
             <a:endParaRPr lang="zh-CN" altLang="en-US"/>
           </a:p>
@@ -2074,7 +2076,7 @@
           <a:p>
             <a:fld id="{3F567BA6-CBC2-4FF0-810E-3ED1BF2C4381}" type="datetimeFigureOut">
               <a:rPr lang="zh-CN" altLang="en-US" smtClean="0"/>
-              <a:t>2025/12/4</a:t>
+              <a:t>2025/12/11</a:t>
             </a:fld>
             <a:endParaRPr lang="zh-CN" altLang="en-US"/>
           </a:p>
@@ -2385,7 +2387,7 @@
           <a:p>
             <a:fld id="{3F567BA6-CBC2-4FF0-810E-3ED1BF2C4381}" type="datetimeFigureOut">
               <a:rPr lang="zh-CN" altLang="en-US" smtClean="0"/>
-              <a:t>2025/12/4</a:t>
+              <a:t>2025/12/11</a:t>
             </a:fld>
             <a:endParaRPr lang="zh-CN" altLang="en-US"/>
           </a:p>
@@ -2673,7 +2675,7 @@
           <a:p>
             <a:fld id="{3F567BA6-CBC2-4FF0-810E-3ED1BF2C4381}" type="datetimeFigureOut">
               <a:rPr lang="zh-CN" altLang="en-US" smtClean="0"/>
-              <a:t>2025/12/4</a:t>
+              <a:t>2025/12/11</a:t>
             </a:fld>
             <a:endParaRPr lang="zh-CN" altLang="en-US"/>
           </a:p>
@@ -2914,7 +2916,7 @@
           <a:p>
             <a:fld id="{3F567BA6-CBC2-4FF0-810E-3ED1BF2C4381}" type="datetimeFigureOut">
               <a:rPr lang="zh-CN" altLang="en-US" smtClean="0"/>
-              <a:t>2025/12/4</a:t>
+              <a:t>2025/12/11</a:t>
             </a:fld>
             <a:endParaRPr lang="zh-CN" altLang="en-US"/>
           </a:p>
@@ -3752,13 +3754,7 @@
   <p:cSld>
     <p:spTree>
       <p:nvGrpSpPr>
-        <p:cNvPr id="1" name="">
-          <a:extLst>
-            <a:ext uri="{FF2B5EF4-FFF2-40B4-BE49-F238E27FC236}">
-              <a16:creationId xmlns:a16="http://schemas.microsoft.com/office/drawing/2014/main" id="{FC024BB9-73A1-D41C-F92F-3EA3D4F15D0C}"/>
-            </a:ext>
-          </a:extLst>
-        </p:cNvPr>
+        <p:cNvPr id="1" name=""/>
         <p:cNvGrpSpPr/>
         <p:nvPr/>
       </p:nvGrpSpPr>
@@ -3775,7 +3771,7 @@
           <p:cNvPr id="4" name="文本框 3">
             <a:extLst>
               <a:ext uri="{FF2B5EF4-FFF2-40B4-BE49-F238E27FC236}">
-                <a16:creationId xmlns:a16="http://schemas.microsoft.com/office/drawing/2014/main" id="{6F8B3972-7AD1-1633-2C19-92F39550E868}"/>
+                <a16:creationId xmlns:a16="http://schemas.microsoft.com/office/drawing/2014/main" id="{A898100F-D511-C3F5-4EF0-57F49F02315C}"/>
               </a:ext>
             </a:extLst>
           </p:cNvPr>
@@ -3785,7 +3781,7 @@
         <p:spPr>
           <a:xfrm>
             <a:off x="479719" y="151179"/>
-            <a:ext cx="11219222" cy="5447645"/>
+            <a:ext cx="11219222" cy="4278094"/>
           </a:xfrm>
           <a:prstGeom prst="rect">
             <a:avLst/>
@@ -3803,8 +3799,10 @@
                 <a:latin typeface="Arial" panose="020B0604020202020204" pitchFamily="34" charset="0"/>
                 <a:cs typeface="Arial" panose="020B0604020202020204" pitchFamily="34" charset="0"/>
               </a:rPr>
-              <a:t>Comparison experiment</a:t>
-            </a:r>
+              <a:t>Verbalized Sampling:</a:t>
+            </a:r>
+          </a:p>
+          <a:p>
             <a:endParaRPr lang="en-US" altLang="zh-CN" sz="2000" dirty="0">
               <a:latin typeface="Arial" panose="020B0604020202020204" pitchFamily="34" charset="0"/>
               <a:cs typeface="Arial" panose="020B0604020202020204" pitchFamily="34" charset="0"/>
@@ -3812,132 +3810,49 @@
           </a:p>
           <a:p>
             <a:r>
-              <a:rPr lang="en-US" altLang="zh-CN" sz="2400" b="1" dirty="0">
-                <a:latin typeface="Arial" panose="020B0604020202020204" pitchFamily="34" charset="0"/>
-                <a:cs typeface="Arial" panose="020B0604020202020204" pitchFamily="34" charset="0"/>
-              </a:rPr>
-              <a:t>Experiment dataset: </a:t>
-            </a:r>
-            <a:r>
-              <a:rPr lang="en-US" altLang="zh-CN" sz="2000" b="1" dirty="0">
-                <a:latin typeface="Arial" panose="020B0604020202020204" pitchFamily="34" charset="0"/>
-                <a:cs typeface="Arial" panose="020B0604020202020204" pitchFamily="34" charset="0"/>
-              </a:rPr>
-              <a:t>100 samples from </a:t>
-            </a:r>
-            <a:r>
-              <a:rPr lang="en-US" altLang="zh-CN" sz="2000" b="1" dirty="0" err="1">
-                <a:latin typeface="Arial" panose="020B0604020202020204" pitchFamily="34" charset="0"/>
-                <a:cs typeface="Arial" panose="020B0604020202020204" pitchFamily="34" charset="0"/>
-              </a:rPr>
-              <a:t>TruthfulQA</a:t>
-            </a:r>
-            <a:r>
-              <a:rPr lang="en-US" altLang="zh-CN" sz="2000" b="1" dirty="0">
-                <a:latin typeface="Arial" panose="020B0604020202020204" pitchFamily="34" charset="0"/>
-                <a:cs typeface="Arial" panose="020B0604020202020204" pitchFamily="34" charset="0"/>
-              </a:rPr>
-              <a:t>, with 49 hallucination samples and 51 correct samples</a:t>
-            </a:r>
+              <a:rPr lang="en-US" altLang="zh-CN" sz="2000" dirty="0">
+                <a:solidFill>
+                  <a:srgbClr val="FF0000"/>
+                </a:solidFill>
+                <a:latin typeface="Arial" panose="020B0604020202020204" pitchFamily="34" charset="0"/>
+                <a:cs typeface="Arial" panose="020B0604020202020204" pitchFamily="34" charset="0"/>
+              </a:rPr>
+              <a:t>System prompt</a:t>
+            </a:r>
+            <a:r>
+              <a:rPr lang="en-US" altLang="zh-CN" sz="2000" dirty="0">
+                <a:latin typeface="Arial" panose="020B0604020202020204" pitchFamily="34" charset="0"/>
+                <a:cs typeface="Arial" panose="020B0604020202020204" pitchFamily="34" charset="0"/>
+              </a:rPr>
+              <a:t>: You are a helpful assistant. For each query, please generate a set of five possible responses, each within a separate &lt;response&gt; tag. Responses should each include a &lt;text&gt; and a numeric &lt;probability&gt;. Please sample at random from the [full distribution / tails of the distribution, such that the probability of each response is less than 0.10].</a:t>
+            </a:r>
+          </a:p>
+          <a:p>
+            <a:r>
+              <a:rPr lang="en-US" altLang="zh-CN" sz="2000" dirty="0">
+                <a:solidFill>
+                  <a:srgbClr val="FF0000"/>
+                </a:solidFill>
+                <a:latin typeface="Arial" panose="020B0604020202020204" pitchFamily="34" charset="0"/>
+                <a:cs typeface="Arial" panose="020B0604020202020204" pitchFamily="34" charset="0"/>
+              </a:rPr>
+              <a:t>User prompt</a:t>
+            </a:r>
+            <a:r>
+              <a:rPr lang="en-US" altLang="zh-CN" sz="2000" dirty="0">
+                <a:latin typeface="Arial" panose="020B0604020202020204" pitchFamily="34" charset="0"/>
+                <a:cs typeface="Arial" panose="020B0604020202020204" pitchFamily="34" charset="0"/>
+              </a:rPr>
+              <a:t>: …</a:t>
+            </a:r>
+          </a:p>
+          <a:p>
             <a:endParaRPr lang="en-US" altLang="zh-CN" sz="2000" dirty="0">
               <a:latin typeface="Arial" panose="020B0604020202020204" pitchFamily="34" charset="0"/>
               <a:cs typeface="Arial" panose="020B0604020202020204" pitchFamily="34" charset="0"/>
             </a:endParaRPr>
           </a:p>
           <a:p>
-            <a:endParaRPr lang="en-US" altLang="zh-CN" sz="2000" b="1" dirty="0">
-              <a:latin typeface="Arial" panose="020B0604020202020204" pitchFamily="34" charset="0"/>
-              <a:cs typeface="Arial" panose="020B0604020202020204" pitchFamily="34" charset="0"/>
-            </a:endParaRPr>
-          </a:p>
-          <a:p>
-            <a:r>
-              <a:rPr lang="en-US" altLang="zh-CN" sz="2400" b="1" dirty="0">
-                <a:latin typeface="Arial" panose="020B0604020202020204" pitchFamily="34" charset="0"/>
-                <a:cs typeface="Arial" panose="020B0604020202020204" pitchFamily="34" charset="0"/>
-              </a:rPr>
-              <a:t>Baseline: </a:t>
-            </a:r>
-            <a:r>
-              <a:rPr lang="en-US" altLang="zh-CN" sz="2000" dirty="0" err="1">
-                <a:latin typeface="Arial" panose="020B0604020202020204" pitchFamily="34" charset="0"/>
-                <a:cs typeface="Arial" panose="020B0604020202020204" pitchFamily="34" charset="0"/>
-              </a:rPr>
-              <a:t>CoT</a:t>
-            </a:r>
-            <a:r>
-              <a:rPr lang="en-US" altLang="zh-CN" sz="2000" dirty="0">
-                <a:latin typeface="Arial" panose="020B0604020202020204" pitchFamily="34" charset="0"/>
-                <a:cs typeface="Arial" panose="020B0604020202020204" pitchFamily="34" charset="0"/>
-              </a:rPr>
-              <a:t>(chain-of-thought, Google </a:t>
-            </a:r>
-            <a:r>
-              <a:rPr lang="en-US" altLang="zh-CN" sz="2000" dirty="0" err="1">
-                <a:latin typeface="Arial" panose="020B0604020202020204" pitchFamily="34" charset="0"/>
-                <a:cs typeface="Arial" panose="020B0604020202020204" pitchFamily="34" charset="0"/>
-              </a:rPr>
-              <a:t>Reseach</a:t>
-            </a:r>
-            <a:r>
-              <a:rPr lang="en-US" altLang="zh-CN" sz="2000" dirty="0">
-                <a:latin typeface="Arial" panose="020B0604020202020204" pitchFamily="34" charset="0"/>
-                <a:cs typeface="Arial" panose="020B0604020202020204" pitchFamily="34" charset="0"/>
-              </a:rPr>
-              <a:t>), </a:t>
-            </a:r>
-            <a:r>
-              <a:rPr lang="en-US" altLang="zh-CN" sz="2000" dirty="0" err="1">
-                <a:latin typeface="Arial" panose="020B0604020202020204" pitchFamily="34" charset="0"/>
-                <a:cs typeface="Arial" panose="020B0604020202020204" pitchFamily="34" charset="0"/>
-              </a:rPr>
-              <a:t>CoVe</a:t>
-            </a:r>
-            <a:r>
-              <a:rPr lang="en-US" altLang="zh-CN" sz="2000" dirty="0">
-                <a:latin typeface="Arial" panose="020B0604020202020204" pitchFamily="34" charset="0"/>
-                <a:cs typeface="Arial" panose="020B0604020202020204" pitchFamily="34" charset="0"/>
-              </a:rPr>
-              <a:t>(chain-of-verification, </a:t>
-            </a:r>
-            <a:r>
-              <a:rPr lang="en-US" altLang="zh-CN" sz="2000" dirty="0" err="1">
-                <a:latin typeface="Arial" panose="020B0604020202020204" pitchFamily="34" charset="0"/>
-                <a:cs typeface="Arial" panose="020B0604020202020204" pitchFamily="34" charset="0"/>
-              </a:rPr>
-              <a:t>MetaAI</a:t>
-            </a:r>
-            <a:r>
-              <a:rPr lang="en-US" altLang="zh-CN" sz="2000" dirty="0">
-                <a:latin typeface="Arial" panose="020B0604020202020204" pitchFamily="34" charset="0"/>
-                <a:cs typeface="Arial" panose="020B0604020202020204" pitchFamily="34" charset="0"/>
-              </a:rPr>
-              <a:t>)</a:t>
-            </a:r>
-          </a:p>
-          <a:p>
-            <a:endParaRPr lang="en-US" altLang="zh-CN" sz="2000" b="1" dirty="0">
-              <a:latin typeface="Arial" panose="020B0604020202020204" pitchFamily="34" charset="0"/>
-              <a:cs typeface="Arial" panose="020B0604020202020204" pitchFamily="34" charset="0"/>
-            </a:endParaRPr>
-          </a:p>
-          <a:p>
-            <a:r>
-              <a:rPr lang="en-US" altLang="zh-CN" sz="2400" b="1" dirty="0">
-                <a:latin typeface="Arial" panose="020B0604020202020204" pitchFamily="34" charset="0"/>
-                <a:cs typeface="Arial" panose="020B0604020202020204" pitchFamily="34" charset="0"/>
-              </a:rPr>
-              <a:t>Experiment result parameters:</a:t>
-            </a:r>
-          </a:p>
-          <a:p>
-            <a:r>
-              <a:rPr lang="en-US" altLang="zh-CN" sz="2000" dirty="0">
-                <a:latin typeface="Arial" panose="020B0604020202020204" pitchFamily="34" charset="0"/>
-                <a:cs typeface="Arial" panose="020B0604020202020204" pitchFamily="34" charset="0"/>
-              </a:rPr>
-              <a:t>hallucination rate after repair: </a:t>
-            </a:r>
             <a:r>
               <a:rPr lang="en-US" altLang="zh-CN" sz="2000" dirty="0">
                 <a:solidFill>
@@ -3946,35 +3861,23 @@
                 <a:latin typeface="Arial" panose="020B0604020202020204" pitchFamily="34" charset="0"/>
                 <a:cs typeface="Arial" panose="020B0604020202020204" pitchFamily="34" charset="0"/>
               </a:rPr>
-              <a:t>hallucination</a:t>
+              <a:t>Output</a:t>
             </a:r>
             <a:r>
               <a:rPr lang="en-US" altLang="zh-CN" sz="2000" dirty="0">
                 <a:latin typeface="Arial" panose="020B0604020202020204" pitchFamily="34" charset="0"/>
                 <a:cs typeface="Arial" panose="020B0604020202020204" pitchFamily="34" charset="0"/>
               </a:rPr>
-              <a:t> in </a:t>
-            </a:r>
-            <a:r>
-              <a:rPr lang="en-US" altLang="zh-CN" sz="2000" b="1" dirty="0" err="1">
-                <a:latin typeface="Arial" panose="020B0604020202020204" pitchFamily="34" charset="0"/>
-                <a:cs typeface="Arial" panose="020B0604020202020204" pitchFamily="34" charset="0"/>
-              </a:rPr>
-              <a:t>final_answer</a:t>
-            </a:r>
-            <a:r>
-              <a:rPr lang="en-US" altLang="zh-CN" sz="2000" b="1" dirty="0">
-                <a:latin typeface="Arial" panose="020B0604020202020204" pitchFamily="34" charset="0"/>
-                <a:cs typeface="Arial" panose="020B0604020202020204" pitchFamily="34" charset="0"/>
-              </a:rPr>
-              <a:t> </a:t>
-            </a:r>
+              <a:t>:</a:t>
+            </a:r>
+          </a:p>
+          <a:p>
             <a:r>
               <a:rPr lang="en-US" altLang="zh-CN" sz="2000" dirty="0">
                 <a:latin typeface="Arial" panose="020B0604020202020204" pitchFamily="34" charset="0"/>
                 <a:cs typeface="Arial" panose="020B0604020202020204" pitchFamily="34" charset="0"/>
               </a:rPr>
-              <a:t>provided by approaches</a:t>
+              <a:t>&lt;response&gt;</a:t>
             </a:r>
           </a:p>
           <a:p>
@@ -3983,288 +3886,25 @@
                 <a:latin typeface="Arial" panose="020B0604020202020204" pitchFamily="34" charset="0"/>
                 <a:cs typeface="Arial" panose="020B0604020202020204" pitchFamily="34" charset="0"/>
               </a:rPr>
-              <a:t>hallucination repair: </a:t>
-            </a:r>
-            <a:r>
-              <a:rPr lang="en-US" altLang="zh-CN" sz="2000" b="1" dirty="0" err="1">
-                <a:latin typeface="Arial" panose="020B0604020202020204" pitchFamily="34" charset="0"/>
-                <a:cs typeface="Arial" panose="020B0604020202020204" pitchFamily="34" charset="0"/>
-              </a:rPr>
-              <a:t>base_response</a:t>
-            </a:r>
-            <a:r>
-              <a:rPr lang="en-US" altLang="zh-CN" sz="2000" b="1" dirty="0">
-                <a:latin typeface="Arial" panose="020B0604020202020204" pitchFamily="34" charset="0"/>
-                <a:cs typeface="Arial" panose="020B0604020202020204" pitchFamily="34" charset="0"/>
-              </a:rPr>
-              <a:t> </a:t>
-            </a:r>
+              <a:t>&lt;text&gt;context&lt;/text&gt;</a:t>
+            </a:r>
+          </a:p>
+          <a:p>
             <a:r>
               <a:rPr lang="en-US" altLang="zh-CN" sz="2000" dirty="0">
                 <a:latin typeface="Arial" panose="020B0604020202020204" pitchFamily="34" charset="0"/>
                 <a:cs typeface="Arial" panose="020B0604020202020204" pitchFamily="34" charset="0"/>
               </a:rPr>
-              <a:t>= </a:t>
-            </a:r>
+              <a:t>&lt;probability&gt;X&lt;/probability&gt;	X=The probability that the LLM will output this context</a:t>
+            </a:r>
+          </a:p>
+          <a:p>
             <a:r>
               <a:rPr lang="en-US" altLang="zh-CN" sz="2000" dirty="0">
-                <a:solidFill>
-                  <a:srgbClr val="FF0000"/>
-                </a:solidFill>
-                <a:latin typeface="Arial" panose="020B0604020202020204" pitchFamily="34" charset="0"/>
-                <a:cs typeface="Arial" panose="020B0604020202020204" pitchFamily="34" charset="0"/>
-              </a:rPr>
-              <a:t>hallucination</a:t>
-            </a:r>
-            <a:r>
-              <a:rPr lang="en-US" altLang="zh-CN" sz="2000" dirty="0">
-                <a:latin typeface="Arial" panose="020B0604020202020204" pitchFamily="34" charset="0"/>
-                <a:cs typeface="Arial" panose="020B0604020202020204" pitchFamily="34" charset="0"/>
-              </a:rPr>
-              <a:t>, </a:t>
-            </a:r>
-            <a:r>
-              <a:rPr lang="en-US" altLang="zh-CN" sz="2000" b="1" dirty="0" err="1">
-                <a:latin typeface="Arial" panose="020B0604020202020204" pitchFamily="34" charset="0"/>
-                <a:cs typeface="Arial" panose="020B0604020202020204" pitchFamily="34" charset="0"/>
-              </a:rPr>
-              <a:t>final_answer</a:t>
-            </a:r>
-            <a:r>
-              <a:rPr lang="en-US" altLang="zh-CN" sz="2000" b="1" dirty="0">
-                <a:latin typeface="Arial" panose="020B0604020202020204" pitchFamily="34" charset="0"/>
-                <a:cs typeface="Arial" panose="020B0604020202020204" pitchFamily="34" charset="0"/>
-              </a:rPr>
-              <a:t> </a:t>
-            </a:r>
-            <a:r>
-              <a:rPr lang="en-US" altLang="zh-CN" sz="2000" dirty="0">
-                <a:latin typeface="Arial" panose="020B0604020202020204" pitchFamily="34" charset="0"/>
-                <a:cs typeface="Arial" panose="020B0604020202020204" pitchFamily="34" charset="0"/>
-              </a:rPr>
-              <a:t>= </a:t>
-            </a:r>
-            <a:r>
-              <a:rPr lang="en-US" altLang="zh-CN" sz="2000" dirty="0">
-                <a:solidFill>
-                  <a:schemeClr val="accent1"/>
-                </a:solidFill>
-                <a:latin typeface="Arial" panose="020B0604020202020204" pitchFamily="34" charset="0"/>
-                <a:cs typeface="Arial" panose="020B0604020202020204" pitchFamily="34" charset="0"/>
-              </a:rPr>
-              <a:t>not hallucination</a:t>
-            </a:r>
-          </a:p>
-          <a:p>
-            <a:r>
-              <a:rPr lang="en-US" altLang="zh-CN" sz="2000" dirty="0">
-                <a:latin typeface="Arial" panose="020B0604020202020204" pitchFamily="34" charset="0"/>
-                <a:cs typeface="Arial" panose="020B0604020202020204" pitchFamily="34" charset="0"/>
-              </a:rPr>
-              <a:t>unsuccessful repair: </a:t>
-            </a:r>
-            <a:r>
-              <a:rPr lang="en-US" altLang="zh-CN" sz="2000" b="1" dirty="0" err="1">
-                <a:latin typeface="Arial" panose="020B0604020202020204" pitchFamily="34" charset="0"/>
-                <a:cs typeface="Arial" panose="020B0604020202020204" pitchFamily="34" charset="0"/>
-              </a:rPr>
-              <a:t>base_response</a:t>
-            </a:r>
-            <a:r>
-              <a:rPr lang="en-US" altLang="zh-CN" sz="2000" b="1" dirty="0">
-                <a:latin typeface="Arial" panose="020B0604020202020204" pitchFamily="34" charset="0"/>
-                <a:cs typeface="Arial" panose="020B0604020202020204" pitchFamily="34" charset="0"/>
-              </a:rPr>
-              <a:t> </a:t>
-            </a:r>
-            <a:r>
-              <a:rPr lang="en-US" altLang="zh-CN" sz="2000" dirty="0">
-                <a:latin typeface="Arial" panose="020B0604020202020204" pitchFamily="34" charset="0"/>
-                <a:cs typeface="Arial" panose="020B0604020202020204" pitchFamily="34" charset="0"/>
-              </a:rPr>
-              <a:t>= </a:t>
-            </a:r>
-            <a:r>
-              <a:rPr lang="en-US" altLang="zh-CN" sz="2000" dirty="0">
-                <a:solidFill>
-                  <a:srgbClr val="FF0000"/>
-                </a:solidFill>
-                <a:latin typeface="Arial" panose="020B0604020202020204" pitchFamily="34" charset="0"/>
-                <a:cs typeface="Arial" panose="020B0604020202020204" pitchFamily="34" charset="0"/>
-              </a:rPr>
-              <a:t>hallucination</a:t>
-            </a:r>
-            <a:r>
-              <a:rPr lang="en-US" altLang="zh-CN" sz="2000" dirty="0">
-                <a:latin typeface="Arial" panose="020B0604020202020204" pitchFamily="34" charset="0"/>
-                <a:cs typeface="Arial" panose="020B0604020202020204" pitchFamily="34" charset="0"/>
-              </a:rPr>
-              <a:t>, </a:t>
-            </a:r>
-            <a:r>
-              <a:rPr lang="en-US" altLang="zh-CN" sz="2000" b="1" dirty="0" err="1">
-                <a:latin typeface="Arial" panose="020B0604020202020204" pitchFamily="34" charset="0"/>
-                <a:cs typeface="Arial" panose="020B0604020202020204" pitchFamily="34" charset="0"/>
-              </a:rPr>
-              <a:t>final_answer</a:t>
-            </a:r>
-            <a:r>
-              <a:rPr lang="en-US" altLang="zh-CN" sz="2000" dirty="0">
-                <a:latin typeface="Arial" panose="020B0604020202020204" pitchFamily="34" charset="0"/>
-                <a:cs typeface="Arial" panose="020B0604020202020204" pitchFamily="34" charset="0"/>
-              </a:rPr>
-              <a:t> = </a:t>
-            </a:r>
-            <a:r>
-              <a:rPr lang="en-US" altLang="zh-CN" sz="2000" dirty="0">
-                <a:solidFill>
-                  <a:srgbClr val="FF0000"/>
-                </a:solidFill>
-                <a:latin typeface="Arial" panose="020B0604020202020204" pitchFamily="34" charset="0"/>
-                <a:cs typeface="Arial" panose="020B0604020202020204" pitchFamily="34" charset="0"/>
-              </a:rPr>
-              <a:t>hallucination</a:t>
-            </a:r>
-          </a:p>
-          <a:p>
-            <a:r>
-              <a:rPr lang="en-US" altLang="zh-CN" sz="2000" dirty="0">
-                <a:latin typeface="Arial" panose="020B0604020202020204" pitchFamily="34" charset="0"/>
-                <a:cs typeface="Arial" panose="020B0604020202020204" pitchFamily="34" charset="0"/>
-              </a:rPr>
-              <a:t>overcorrection: </a:t>
-            </a:r>
-            <a:r>
-              <a:rPr lang="en-US" altLang="zh-CN" sz="2000" b="1" dirty="0" err="1">
-                <a:latin typeface="Arial" panose="020B0604020202020204" pitchFamily="34" charset="0"/>
-                <a:cs typeface="Arial" panose="020B0604020202020204" pitchFamily="34" charset="0"/>
-              </a:rPr>
-              <a:t>base_response</a:t>
-            </a:r>
-            <a:r>
-              <a:rPr lang="en-US" altLang="zh-CN" sz="2000" b="1" dirty="0">
-                <a:latin typeface="Arial" panose="020B0604020202020204" pitchFamily="34" charset="0"/>
-                <a:cs typeface="Arial" panose="020B0604020202020204" pitchFamily="34" charset="0"/>
-              </a:rPr>
-              <a:t> </a:t>
-            </a:r>
-            <a:r>
-              <a:rPr lang="en-US" altLang="zh-CN" sz="2000" dirty="0">
-                <a:latin typeface="Arial" panose="020B0604020202020204" pitchFamily="34" charset="0"/>
-                <a:cs typeface="Arial" panose="020B0604020202020204" pitchFamily="34" charset="0"/>
-              </a:rPr>
-              <a:t>= </a:t>
-            </a:r>
-            <a:r>
-              <a:rPr lang="en-US" altLang="zh-CN" sz="2000" dirty="0">
-                <a:solidFill>
-                  <a:schemeClr val="accent1"/>
-                </a:solidFill>
-                <a:latin typeface="Arial" panose="020B0604020202020204" pitchFamily="34" charset="0"/>
-                <a:cs typeface="Arial" panose="020B0604020202020204" pitchFamily="34" charset="0"/>
-              </a:rPr>
-              <a:t>not hallucination</a:t>
-            </a:r>
-            <a:r>
-              <a:rPr lang="en-US" altLang="zh-CN" sz="2000" dirty="0">
-                <a:latin typeface="Arial" panose="020B0604020202020204" pitchFamily="34" charset="0"/>
-                <a:cs typeface="Arial" panose="020B0604020202020204" pitchFamily="34" charset="0"/>
-              </a:rPr>
-              <a:t>, </a:t>
-            </a:r>
-            <a:r>
-              <a:rPr lang="en-US" altLang="zh-CN" sz="2000" b="1" dirty="0" err="1">
-                <a:latin typeface="Arial" panose="020B0604020202020204" pitchFamily="34" charset="0"/>
-                <a:cs typeface="Arial" panose="020B0604020202020204" pitchFamily="34" charset="0"/>
-              </a:rPr>
-              <a:t>final_answer</a:t>
-            </a:r>
-            <a:r>
-              <a:rPr lang="en-US" altLang="zh-CN" sz="2000" b="1" dirty="0">
-                <a:latin typeface="Arial" panose="020B0604020202020204" pitchFamily="34" charset="0"/>
-                <a:cs typeface="Arial" panose="020B0604020202020204" pitchFamily="34" charset="0"/>
-              </a:rPr>
-              <a:t> </a:t>
-            </a:r>
-            <a:r>
-              <a:rPr lang="en-US" altLang="zh-CN" sz="2000" dirty="0">
-                <a:latin typeface="Arial" panose="020B0604020202020204" pitchFamily="34" charset="0"/>
-                <a:cs typeface="Arial" panose="020B0604020202020204" pitchFamily="34" charset="0"/>
-              </a:rPr>
-              <a:t>= </a:t>
-            </a:r>
-            <a:r>
-              <a:rPr lang="en-US" altLang="zh-CN" sz="2000" dirty="0">
-                <a:solidFill>
-                  <a:srgbClr val="FF0000"/>
-                </a:solidFill>
-                <a:latin typeface="Arial" panose="020B0604020202020204" pitchFamily="34" charset="0"/>
-                <a:cs typeface="Arial" panose="020B0604020202020204" pitchFamily="34" charset="0"/>
-              </a:rPr>
-              <a:t>hallucination</a:t>
-            </a:r>
-          </a:p>
-          <a:p>
-            <a:r>
-              <a:rPr lang="en-US" altLang="zh-CN" sz="2000" dirty="0">
-                <a:latin typeface="Arial" panose="020B0604020202020204" pitchFamily="34" charset="0"/>
-                <a:cs typeface="Arial" panose="020B0604020202020204" pitchFamily="34" charset="0"/>
-              </a:rPr>
-              <a:t>pass@6: at least 1 is correct in the checking results of (mutations + </a:t>
-            </a:r>
-            <a:r>
-              <a:rPr lang="en-US" altLang="zh-CN" sz="2000" dirty="0" err="1">
-                <a:latin typeface="Arial" panose="020B0604020202020204" pitchFamily="34" charset="0"/>
-                <a:cs typeface="Arial" panose="020B0604020202020204" pitchFamily="34" charset="0"/>
-              </a:rPr>
-              <a:t>base_response</a:t>
-            </a:r>
-            <a:r>
-              <a:rPr lang="en-US" altLang="zh-CN" sz="2000" dirty="0">
-                <a:latin typeface="Arial" panose="020B0604020202020204" pitchFamily="34" charset="0"/>
-                <a:cs typeface="Arial" panose="020B0604020202020204" pitchFamily="34" charset="0"/>
-              </a:rPr>
-              <a:t>)</a:t>
-            </a:r>
-          </a:p>
-          <a:p>
-            <a:r>
-              <a:rPr lang="en-US" altLang="zh-CN" sz="2000" dirty="0">
-                <a:latin typeface="Arial" panose="020B0604020202020204" pitchFamily="34" charset="0"/>
-                <a:cs typeface="Arial" panose="020B0604020202020204" pitchFamily="34" charset="0"/>
-              </a:rPr>
-              <a:t>avg token cost pre question</a:t>
-            </a:r>
-          </a:p>
-          <a:p>
-            <a:r>
-              <a:rPr lang="en-US" altLang="zh-CN" sz="2000" dirty="0">
-                <a:latin typeface="Arial" panose="020B0604020202020204" pitchFamily="34" charset="0"/>
-                <a:cs typeface="Arial" panose="020B0604020202020204" pitchFamily="34" charset="0"/>
-              </a:rPr>
-              <a:t>avg time cost pre question</a:t>
-            </a:r>
-          </a:p>
-          <a:p>
-            <a:endParaRPr lang="en-US" altLang="zh-CN" sz="2000" dirty="0">
-              <a:latin typeface="Arial" panose="020B0604020202020204" pitchFamily="34" charset="0"/>
-              <a:cs typeface="Arial" panose="020B0604020202020204" pitchFamily="34" charset="0"/>
-            </a:endParaRPr>
-          </a:p>
-          <a:p>
-            <a:r>
-              <a:rPr lang="en-US" altLang="zh-CN" sz="2400" b="1" dirty="0">
-                <a:latin typeface="Arial" panose="020B0604020202020204" pitchFamily="34" charset="0"/>
-                <a:cs typeface="Arial" panose="020B0604020202020204" pitchFamily="34" charset="0"/>
-              </a:rPr>
-              <a:t>Number of mutations: </a:t>
-            </a:r>
-            <a:r>
-              <a:rPr lang="en-US" altLang="zh-CN" sz="2000" dirty="0">
-                <a:latin typeface="Arial" panose="020B0604020202020204" pitchFamily="34" charset="0"/>
-                <a:cs typeface="Arial" panose="020B0604020202020204" pitchFamily="34" charset="0"/>
-              </a:rPr>
-              <a:t>5(synonym)</a:t>
+                <a:latin typeface="Arial" panose="020B0604020202020204" pitchFamily="34" charset="0"/>
+                <a:cs typeface="Arial" panose="020B0604020202020204" pitchFamily="34" charset="0"/>
+              </a:rPr>
+              <a:t>…</a:t>
             </a:r>
           </a:p>
         </p:txBody>
@@ -4272,7 +3912,7 @@
     </p:spTree>
     <p:extLst>
       <p:ext uri="{BB962C8B-B14F-4D97-AF65-F5344CB8AC3E}">
-        <p14:creationId xmlns:p14="http://schemas.microsoft.com/office/powerpoint/2010/main" val="947931490"/>
+        <p14:creationId xmlns:p14="http://schemas.microsoft.com/office/powerpoint/2010/main" val="3320490622"/>
       </p:ext>
     </p:extLst>
   </p:cSld>
@@ -4301,6 +3941,766 @@
       </p:grpSpPr>
       <p:sp>
         <p:nvSpPr>
+          <p:cNvPr id="4" name="文本框 3">
+            <a:extLst>
+              <a:ext uri="{FF2B5EF4-FFF2-40B4-BE49-F238E27FC236}">
+                <a16:creationId xmlns:a16="http://schemas.microsoft.com/office/drawing/2014/main" id="{1D03348E-BD1F-CC99-2F45-C1012472DEE4}"/>
+              </a:ext>
+            </a:extLst>
+          </p:cNvPr>
+          <p:cNvSpPr txBox="1"/>
+          <p:nvPr/>
+        </p:nvSpPr>
+        <p:spPr>
+          <a:xfrm>
+            <a:off x="479719" y="151179"/>
+            <a:ext cx="11219222" cy="5201424"/>
+          </a:xfrm>
+          <a:prstGeom prst="rect">
+            <a:avLst/>
+          </a:prstGeom>
+          <a:noFill/>
+        </p:spPr>
+        <p:txBody>
+          <a:bodyPr wrap="square" rtlCol="0">
+            <a:spAutoFit/>
+          </a:bodyPr>
+          <a:lstStyle/>
+          <a:p>
+            <a:r>
+              <a:rPr lang="en-US" altLang="zh-CN" sz="3200" dirty="0">
+                <a:latin typeface="Arial" panose="020B0604020202020204" pitchFamily="34" charset="0"/>
+                <a:cs typeface="Arial" panose="020B0604020202020204" pitchFamily="34" charset="0"/>
+              </a:rPr>
+              <a:t>Enhanced Verbalized Sampling:</a:t>
+            </a:r>
+          </a:p>
+          <a:p>
+            <a:endParaRPr lang="en-US" altLang="zh-CN" sz="2000" dirty="0">
+              <a:latin typeface="Arial" panose="020B0604020202020204" pitchFamily="34" charset="0"/>
+              <a:cs typeface="Arial" panose="020B0604020202020204" pitchFamily="34" charset="0"/>
+            </a:endParaRPr>
+          </a:p>
+          <a:p>
+            <a:r>
+              <a:rPr lang="en-US" altLang="zh-CN" sz="2000" dirty="0">
+                <a:solidFill>
+                  <a:srgbClr val="FF0000"/>
+                </a:solidFill>
+                <a:latin typeface="Arial" panose="020B0604020202020204" pitchFamily="34" charset="0"/>
+                <a:cs typeface="Arial" panose="020B0604020202020204" pitchFamily="34" charset="0"/>
+              </a:rPr>
+              <a:t>System prompt</a:t>
+            </a:r>
+            <a:r>
+              <a:rPr lang="en-US" altLang="zh-CN" sz="2000" dirty="0">
+                <a:latin typeface="Arial" panose="020B0604020202020204" pitchFamily="34" charset="0"/>
+                <a:cs typeface="Arial" panose="020B0604020202020204" pitchFamily="34" charset="0"/>
+              </a:rPr>
+              <a:t>: …</a:t>
+            </a:r>
+          </a:p>
+          <a:p>
+            <a:r>
+              <a:rPr lang="en-US" altLang="zh-CN" sz="2000" dirty="0">
+                <a:latin typeface="Arial" panose="020B0604020202020204" pitchFamily="34" charset="0"/>
+                <a:cs typeface="Arial" panose="020B0604020202020204" pitchFamily="34" charset="0"/>
+              </a:rPr>
+              <a:t>Responses should each include:</a:t>
+            </a:r>
+          </a:p>
+          <a:p>
+            <a:r>
+              <a:rPr lang="en-US" altLang="zh-CN" sz="2000" dirty="0">
+                <a:latin typeface="Arial" panose="020B0604020202020204" pitchFamily="34" charset="0"/>
+                <a:cs typeface="Arial" panose="020B0604020202020204" pitchFamily="34" charset="0"/>
+              </a:rPr>
+              <a:t>…</a:t>
+            </a:r>
+          </a:p>
+          <a:p>
+            <a:r>
+              <a:rPr lang="en-US" altLang="zh-CN" sz="2000" dirty="0">
+                <a:latin typeface="Arial" panose="020B0604020202020204" pitchFamily="34" charset="0"/>
+                <a:cs typeface="Arial" panose="020B0604020202020204" pitchFamily="34" charset="0"/>
+              </a:rPr>
+              <a:t>-a numeric &lt;confidence&gt; field representing the model's confidence score for the factual correctness of the answer (range 0.00–1.00, two decimal places).</a:t>
+            </a:r>
+          </a:p>
+          <a:p>
+            <a:r>
+              <a:rPr lang="en-US" altLang="zh-CN" sz="2000" dirty="0">
+                <a:solidFill>
+                  <a:srgbClr val="FF0000"/>
+                </a:solidFill>
+                <a:latin typeface="Arial" panose="020B0604020202020204" pitchFamily="34" charset="0"/>
+                <a:cs typeface="Arial" panose="020B0604020202020204" pitchFamily="34" charset="0"/>
+              </a:rPr>
+              <a:t>User prompt</a:t>
+            </a:r>
+            <a:r>
+              <a:rPr lang="en-US" altLang="zh-CN" sz="2000" dirty="0">
+                <a:latin typeface="Arial" panose="020B0604020202020204" pitchFamily="34" charset="0"/>
+                <a:cs typeface="Arial" panose="020B0604020202020204" pitchFamily="34" charset="0"/>
+              </a:rPr>
+              <a:t>: …</a:t>
+            </a:r>
+          </a:p>
+          <a:p>
+            <a:endParaRPr lang="en-US" altLang="zh-CN" sz="2000" dirty="0">
+              <a:latin typeface="Arial" panose="020B0604020202020204" pitchFamily="34" charset="0"/>
+              <a:cs typeface="Arial" panose="020B0604020202020204" pitchFamily="34" charset="0"/>
+            </a:endParaRPr>
+          </a:p>
+          <a:p>
+            <a:r>
+              <a:rPr lang="en-US" altLang="zh-CN" sz="2000" dirty="0">
+                <a:solidFill>
+                  <a:srgbClr val="FF0000"/>
+                </a:solidFill>
+                <a:latin typeface="Arial" panose="020B0604020202020204" pitchFamily="34" charset="0"/>
+                <a:cs typeface="Arial" panose="020B0604020202020204" pitchFamily="34" charset="0"/>
+              </a:rPr>
+              <a:t>Output</a:t>
+            </a:r>
+            <a:r>
+              <a:rPr lang="en-US" altLang="zh-CN" sz="2000" dirty="0">
+                <a:latin typeface="Arial" panose="020B0604020202020204" pitchFamily="34" charset="0"/>
+                <a:cs typeface="Arial" panose="020B0604020202020204" pitchFamily="34" charset="0"/>
+              </a:rPr>
+              <a:t>:</a:t>
+            </a:r>
+          </a:p>
+          <a:p>
+            <a:r>
+              <a:rPr lang="en-US" altLang="zh-CN" sz="2000" dirty="0">
+                <a:latin typeface="Arial" panose="020B0604020202020204" pitchFamily="34" charset="0"/>
+                <a:cs typeface="Arial" panose="020B0604020202020204" pitchFamily="34" charset="0"/>
+              </a:rPr>
+              <a:t>&lt;response&gt;</a:t>
+            </a:r>
+          </a:p>
+          <a:p>
+            <a:r>
+              <a:rPr lang="en-US" altLang="zh-CN" sz="2000" dirty="0">
+                <a:latin typeface="Arial" panose="020B0604020202020204" pitchFamily="34" charset="0"/>
+                <a:cs typeface="Arial" panose="020B0604020202020204" pitchFamily="34" charset="0"/>
+              </a:rPr>
+              <a:t>&lt;text&gt;context&lt;/text&gt;</a:t>
+            </a:r>
+          </a:p>
+          <a:p>
+            <a:r>
+              <a:rPr lang="en-US" altLang="zh-CN" sz="2000" dirty="0">
+                <a:latin typeface="Arial" panose="020B0604020202020204" pitchFamily="34" charset="0"/>
+                <a:cs typeface="Arial" panose="020B0604020202020204" pitchFamily="34" charset="0"/>
+              </a:rPr>
+              <a:t>&lt;probability&gt;X&lt;/probability&gt;	X=The probability that the LLM will output this context</a:t>
+            </a:r>
+          </a:p>
+          <a:p>
+            <a:r>
+              <a:rPr lang="en-US" altLang="zh-CN" sz="2000" dirty="0">
+                <a:latin typeface="Arial" panose="020B0604020202020204" pitchFamily="34" charset="0"/>
+                <a:cs typeface="Arial" panose="020B0604020202020204" pitchFamily="34" charset="0"/>
+              </a:rPr>
+              <a:t>&lt;confidence&gt;Y&lt;/confidence&gt;	Y=The model's confidence score for the factual correctness of the context</a:t>
+            </a:r>
+          </a:p>
+          <a:p>
+            <a:r>
+              <a:rPr lang="en-US" altLang="zh-CN" sz="2000" dirty="0">
+                <a:latin typeface="Arial" panose="020B0604020202020204" pitchFamily="34" charset="0"/>
+                <a:cs typeface="Arial" panose="020B0604020202020204" pitchFamily="34" charset="0"/>
+              </a:rPr>
+              <a:t>…</a:t>
+            </a:r>
+          </a:p>
+        </p:txBody>
+      </p:sp>
+    </p:spTree>
+    <p:extLst>
+      <p:ext uri="{BB962C8B-B14F-4D97-AF65-F5344CB8AC3E}">
+        <p14:creationId xmlns:p14="http://schemas.microsoft.com/office/powerpoint/2010/main" val="2642712311"/>
+      </p:ext>
+    </p:extLst>
+  </p:cSld>
+  <p:clrMapOvr>
+    <a:masterClrMapping/>
+  </p:clrMapOvr>
+</p:sld>
+</file>
+
+<file path=ppt/slides/slide5.xml><?xml version="1.0" encoding="utf-8"?>
+<p:sld xmlns:a="http://schemas.openxmlformats.org/drawingml/2006/main" xmlns:r="http://schemas.openxmlformats.org/officeDocument/2006/relationships" xmlns:p="http://schemas.openxmlformats.org/presentationml/2006/main">
+  <p:cSld>
+    <p:spTree>
+      <p:nvGrpSpPr>
+        <p:cNvPr id="1" name="">
+          <a:extLst>
+            <a:ext uri="{FF2B5EF4-FFF2-40B4-BE49-F238E27FC236}">
+              <a16:creationId xmlns:a16="http://schemas.microsoft.com/office/drawing/2014/main" id="{FC024BB9-73A1-D41C-F92F-3EA3D4F15D0C}"/>
+            </a:ext>
+          </a:extLst>
+        </p:cNvPr>
+        <p:cNvGrpSpPr/>
+        <p:nvPr/>
+      </p:nvGrpSpPr>
+      <p:grpSpPr>
+        <a:xfrm>
+          <a:off x="0" y="0"/>
+          <a:ext cx="0" cy="0"/>
+          <a:chOff x="0" y="0"/>
+          <a:chExt cx="0" cy="0"/>
+        </a:xfrm>
+      </p:grpSpPr>
+      <p:sp>
+        <p:nvSpPr>
+          <p:cNvPr id="4" name="文本框 3">
+            <a:extLst>
+              <a:ext uri="{FF2B5EF4-FFF2-40B4-BE49-F238E27FC236}">
+                <a16:creationId xmlns:a16="http://schemas.microsoft.com/office/drawing/2014/main" id="{6F8B3972-7AD1-1633-2C19-92F39550E868}"/>
+              </a:ext>
+            </a:extLst>
+          </p:cNvPr>
+          <p:cNvSpPr txBox="1"/>
+          <p:nvPr/>
+        </p:nvSpPr>
+        <p:spPr>
+          <a:xfrm>
+            <a:off x="479719" y="151179"/>
+            <a:ext cx="11219222" cy="5755422"/>
+          </a:xfrm>
+          <a:prstGeom prst="rect">
+            <a:avLst/>
+          </a:prstGeom>
+          <a:noFill/>
+        </p:spPr>
+        <p:txBody>
+          <a:bodyPr wrap="square" rtlCol="0">
+            <a:spAutoFit/>
+          </a:bodyPr>
+          <a:lstStyle/>
+          <a:p>
+            <a:r>
+              <a:rPr lang="en-US" altLang="zh-CN" sz="3200" dirty="0">
+                <a:latin typeface="Arial" panose="020B0604020202020204" pitchFamily="34" charset="0"/>
+                <a:cs typeface="Arial" panose="020B0604020202020204" pitchFamily="34" charset="0"/>
+              </a:rPr>
+              <a:t>Comparison experiment</a:t>
+            </a:r>
+          </a:p>
+          <a:p>
+            <a:endParaRPr lang="en-US" altLang="zh-CN" sz="2000" dirty="0">
+              <a:latin typeface="Arial" panose="020B0604020202020204" pitchFamily="34" charset="0"/>
+              <a:cs typeface="Arial" panose="020B0604020202020204" pitchFamily="34" charset="0"/>
+            </a:endParaRPr>
+          </a:p>
+          <a:p>
+            <a:r>
+              <a:rPr lang="en-US" altLang="zh-CN" sz="2400" b="1" dirty="0">
+                <a:latin typeface="Arial" panose="020B0604020202020204" pitchFamily="34" charset="0"/>
+                <a:cs typeface="Arial" panose="020B0604020202020204" pitchFamily="34" charset="0"/>
+              </a:rPr>
+              <a:t>Experiment dataset: </a:t>
+            </a:r>
+            <a:r>
+              <a:rPr lang="en-US" altLang="zh-CN" sz="2000" b="1" dirty="0">
+                <a:latin typeface="Arial" panose="020B0604020202020204" pitchFamily="34" charset="0"/>
+                <a:cs typeface="Arial" panose="020B0604020202020204" pitchFamily="34" charset="0"/>
+              </a:rPr>
+              <a:t>150 samples: 100 from </a:t>
+            </a:r>
+            <a:r>
+              <a:rPr lang="en-US" altLang="zh-CN" sz="2000" b="1" dirty="0" err="1">
+                <a:latin typeface="Arial" panose="020B0604020202020204" pitchFamily="34" charset="0"/>
+                <a:cs typeface="Arial" panose="020B0604020202020204" pitchFamily="34" charset="0"/>
+              </a:rPr>
+              <a:t>TruthfulQA</a:t>
+            </a:r>
+            <a:r>
+              <a:rPr lang="en-US" altLang="zh-CN" sz="2000" b="1" dirty="0">
+                <a:latin typeface="Arial" panose="020B0604020202020204" pitchFamily="34" charset="0"/>
+                <a:cs typeface="Arial" panose="020B0604020202020204" pitchFamily="34" charset="0"/>
+              </a:rPr>
+              <a:t>, with 49 hallucination samples. 50 from  </a:t>
+            </a:r>
+            <a:r>
+              <a:rPr lang="en-US" altLang="zh-CN" sz="2000" b="1" dirty="0" err="1">
+                <a:latin typeface="Arial" panose="020B0604020202020204" pitchFamily="34" charset="0"/>
+                <a:cs typeface="Arial" panose="020B0604020202020204" pitchFamily="34" charset="0"/>
+              </a:rPr>
+              <a:t>HotpotQA</a:t>
+            </a:r>
+            <a:r>
+              <a:rPr lang="en-US" altLang="zh-CN" sz="2000" b="1" dirty="0">
+                <a:latin typeface="Arial" panose="020B0604020202020204" pitchFamily="34" charset="0"/>
+                <a:cs typeface="Arial" panose="020B0604020202020204" pitchFamily="34" charset="0"/>
+              </a:rPr>
+              <a:t>, with 25 hallucination samples</a:t>
+            </a:r>
+            <a:endParaRPr lang="en-US" altLang="zh-CN" sz="2000" dirty="0">
+              <a:latin typeface="Arial" panose="020B0604020202020204" pitchFamily="34" charset="0"/>
+              <a:cs typeface="Arial" panose="020B0604020202020204" pitchFamily="34" charset="0"/>
+            </a:endParaRPr>
+          </a:p>
+          <a:p>
+            <a:endParaRPr lang="en-US" altLang="zh-CN" sz="2000" b="1" dirty="0">
+              <a:latin typeface="Arial" panose="020B0604020202020204" pitchFamily="34" charset="0"/>
+              <a:cs typeface="Arial" panose="020B0604020202020204" pitchFamily="34" charset="0"/>
+            </a:endParaRPr>
+          </a:p>
+          <a:p>
+            <a:r>
+              <a:rPr lang="en-US" altLang="zh-CN" sz="2400" b="1" dirty="0">
+                <a:latin typeface="Arial" panose="020B0604020202020204" pitchFamily="34" charset="0"/>
+                <a:cs typeface="Arial" panose="020B0604020202020204" pitchFamily="34" charset="0"/>
+              </a:rPr>
+              <a:t>Baseline: </a:t>
+            </a:r>
+            <a:r>
+              <a:rPr lang="en-US" altLang="zh-CN" sz="2000" dirty="0" err="1">
+                <a:latin typeface="Arial" panose="020B0604020202020204" pitchFamily="34" charset="0"/>
+                <a:cs typeface="Arial" panose="020B0604020202020204" pitchFamily="34" charset="0"/>
+              </a:rPr>
+              <a:t>CoT</a:t>
+            </a:r>
+            <a:r>
+              <a:rPr lang="en-US" altLang="zh-CN" sz="2000" dirty="0">
+                <a:latin typeface="Arial" panose="020B0604020202020204" pitchFamily="34" charset="0"/>
+                <a:cs typeface="Arial" panose="020B0604020202020204" pitchFamily="34" charset="0"/>
+              </a:rPr>
+              <a:t>(chain-of-thought, Google </a:t>
+            </a:r>
+            <a:r>
+              <a:rPr lang="en-US" altLang="zh-CN" sz="2000" dirty="0" err="1">
+                <a:latin typeface="Arial" panose="020B0604020202020204" pitchFamily="34" charset="0"/>
+                <a:cs typeface="Arial" panose="020B0604020202020204" pitchFamily="34" charset="0"/>
+              </a:rPr>
+              <a:t>Reseach</a:t>
+            </a:r>
+            <a:r>
+              <a:rPr lang="en-US" altLang="zh-CN" sz="2000" dirty="0">
+                <a:latin typeface="Arial" panose="020B0604020202020204" pitchFamily="34" charset="0"/>
+                <a:cs typeface="Arial" panose="020B0604020202020204" pitchFamily="34" charset="0"/>
+              </a:rPr>
+              <a:t>), </a:t>
+            </a:r>
+            <a:r>
+              <a:rPr lang="en-US" altLang="zh-CN" sz="2000" dirty="0" err="1">
+                <a:latin typeface="Arial" panose="020B0604020202020204" pitchFamily="34" charset="0"/>
+                <a:cs typeface="Arial" panose="020B0604020202020204" pitchFamily="34" charset="0"/>
+              </a:rPr>
+              <a:t>CoVe</a:t>
+            </a:r>
+            <a:r>
+              <a:rPr lang="en-US" altLang="zh-CN" sz="2000" dirty="0">
+                <a:latin typeface="Arial" panose="020B0604020202020204" pitchFamily="34" charset="0"/>
+                <a:cs typeface="Arial" panose="020B0604020202020204" pitchFamily="34" charset="0"/>
+              </a:rPr>
+              <a:t>(chain-of-verification, </a:t>
+            </a:r>
+            <a:r>
+              <a:rPr lang="en-US" altLang="zh-CN" sz="2000" dirty="0" err="1">
+                <a:latin typeface="Arial" panose="020B0604020202020204" pitchFamily="34" charset="0"/>
+                <a:cs typeface="Arial" panose="020B0604020202020204" pitchFamily="34" charset="0"/>
+              </a:rPr>
+              <a:t>MetaAI</a:t>
+            </a:r>
+            <a:r>
+              <a:rPr lang="en-US" altLang="zh-CN" sz="2000" dirty="0">
+                <a:latin typeface="Arial" panose="020B0604020202020204" pitchFamily="34" charset="0"/>
+                <a:cs typeface="Arial" panose="020B0604020202020204" pitchFamily="34" charset="0"/>
+              </a:rPr>
+              <a:t>)</a:t>
+            </a:r>
+          </a:p>
+          <a:p>
+            <a:endParaRPr lang="en-US" altLang="zh-CN" sz="2000" b="1" dirty="0">
+              <a:latin typeface="Arial" panose="020B0604020202020204" pitchFamily="34" charset="0"/>
+              <a:cs typeface="Arial" panose="020B0604020202020204" pitchFamily="34" charset="0"/>
+            </a:endParaRPr>
+          </a:p>
+          <a:p>
+            <a:r>
+              <a:rPr lang="en-US" altLang="zh-CN" sz="2400" b="1" dirty="0">
+                <a:latin typeface="Arial" panose="020B0604020202020204" pitchFamily="34" charset="0"/>
+                <a:cs typeface="Arial" panose="020B0604020202020204" pitchFamily="34" charset="0"/>
+              </a:rPr>
+              <a:t>Experiment result parameters:</a:t>
+            </a:r>
+          </a:p>
+          <a:p>
+            <a:r>
+              <a:rPr lang="en-US" altLang="zh-CN" sz="2000" dirty="0">
+                <a:latin typeface="Arial" panose="020B0604020202020204" pitchFamily="34" charset="0"/>
+                <a:cs typeface="Arial" panose="020B0604020202020204" pitchFamily="34" charset="0"/>
+              </a:rPr>
+              <a:t>hallucination rate after repair: </a:t>
+            </a:r>
+            <a:r>
+              <a:rPr lang="en-US" altLang="zh-CN" sz="2000" dirty="0">
+                <a:solidFill>
+                  <a:srgbClr val="FF0000"/>
+                </a:solidFill>
+                <a:latin typeface="Arial" panose="020B0604020202020204" pitchFamily="34" charset="0"/>
+                <a:cs typeface="Arial" panose="020B0604020202020204" pitchFamily="34" charset="0"/>
+              </a:rPr>
+              <a:t>hallucination</a:t>
+            </a:r>
+            <a:r>
+              <a:rPr lang="en-US" altLang="zh-CN" sz="2000" dirty="0">
+                <a:latin typeface="Arial" panose="020B0604020202020204" pitchFamily="34" charset="0"/>
+                <a:cs typeface="Arial" panose="020B0604020202020204" pitchFamily="34" charset="0"/>
+              </a:rPr>
+              <a:t> in </a:t>
+            </a:r>
+            <a:r>
+              <a:rPr lang="en-US" altLang="zh-CN" sz="2000" b="1" dirty="0" err="1">
+                <a:latin typeface="Arial" panose="020B0604020202020204" pitchFamily="34" charset="0"/>
+                <a:cs typeface="Arial" panose="020B0604020202020204" pitchFamily="34" charset="0"/>
+              </a:rPr>
+              <a:t>final_answer</a:t>
+            </a:r>
+            <a:r>
+              <a:rPr lang="en-US" altLang="zh-CN" sz="2000" b="1" dirty="0">
+                <a:latin typeface="Arial" panose="020B0604020202020204" pitchFamily="34" charset="0"/>
+                <a:cs typeface="Arial" panose="020B0604020202020204" pitchFamily="34" charset="0"/>
+              </a:rPr>
+              <a:t> </a:t>
+            </a:r>
+            <a:r>
+              <a:rPr lang="en-US" altLang="zh-CN" sz="2000" dirty="0">
+                <a:latin typeface="Arial" panose="020B0604020202020204" pitchFamily="34" charset="0"/>
+                <a:cs typeface="Arial" panose="020B0604020202020204" pitchFamily="34" charset="0"/>
+              </a:rPr>
+              <a:t>provided by approaches</a:t>
+            </a:r>
+          </a:p>
+          <a:p>
+            <a:r>
+              <a:rPr lang="en-US" altLang="zh-CN" sz="2000" dirty="0">
+                <a:latin typeface="Arial" panose="020B0604020202020204" pitchFamily="34" charset="0"/>
+                <a:cs typeface="Arial" panose="020B0604020202020204" pitchFamily="34" charset="0"/>
+              </a:rPr>
+              <a:t>hallucination repair: </a:t>
+            </a:r>
+            <a:r>
+              <a:rPr lang="en-US" altLang="zh-CN" sz="2000" b="1" dirty="0" err="1">
+                <a:latin typeface="Arial" panose="020B0604020202020204" pitchFamily="34" charset="0"/>
+                <a:cs typeface="Arial" panose="020B0604020202020204" pitchFamily="34" charset="0"/>
+              </a:rPr>
+              <a:t>base_response</a:t>
+            </a:r>
+            <a:r>
+              <a:rPr lang="en-US" altLang="zh-CN" sz="2000" b="1" dirty="0">
+                <a:latin typeface="Arial" panose="020B0604020202020204" pitchFamily="34" charset="0"/>
+                <a:cs typeface="Arial" panose="020B0604020202020204" pitchFamily="34" charset="0"/>
+              </a:rPr>
+              <a:t> </a:t>
+            </a:r>
+            <a:r>
+              <a:rPr lang="en-US" altLang="zh-CN" sz="2000" dirty="0">
+                <a:latin typeface="Arial" panose="020B0604020202020204" pitchFamily="34" charset="0"/>
+                <a:cs typeface="Arial" panose="020B0604020202020204" pitchFamily="34" charset="0"/>
+              </a:rPr>
+              <a:t>= </a:t>
+            </a:r>
+            <a:r>
+              <a:rPr lang="en-US" altLang="zh-CN" sz="2000" dirty="0">
+                <a:solidFill>
+                  <a:srgbClr val="FF0000"/>
+                </a:solidFill>
+                <a:latin typeface="Arial" panose="020B0604020202020204" pitchFamily="34" charset="0"/>
+                <a:cs typeface="Arial" panose="020B0604020202020204" pitchFamily="34" charset="0"/>
+              </a:rPr>
+              <a:t>hallucination</a:t>
+            </a:r>
+            <a:r>
+              <a:rPr lang="en-US" altLang="zh-CN" sz="2000" dirty="0">
+                <a:latin typeface="Arial" panose="020B0604020202020204" pitchFamily="34" charset="0"/>
+                <a:cs typeface="Arial" panose="020B0604020202020204" pitchFamily="34" charset="0"/>
+              </a:rPr>
+              <a:t>, </a:t>
+            </a:r>
+            <a:r>
+              <a:rPr lang="en-US" altLang="zh-CN" sz="2000" b="1" dirty="0" err="1">
+                <a:latin typeface="Arial" panose="020B0604020202020204" pitchFamily="34" charset="0"/>
+                <a:cs typeface="Arial" panose="020B0604020202020204" pitchFamily="34" charset="0"/>
+              </a:rPr>
+              <a:t>final_answer</a:t>
+            </a:r>
+            <a:r>
+              <a:rPr lang="en-US" altLang="zh-CN" sz="2000" b="1" dirty="0">
+                <a:latin typeface="Arial" panose="020B0604020202020204" pitchFamily="34" charset="0"/>
+                <a:cs typeface="Arial" panose="020B0604020202020204" pitchFamily="34" charset="0"/>
+              </a:rPr>
+              <a:t> </a:t>
+            </a:r>
+            <a:r>
+              <a:rPr lang="en-US" altLang="zh-CN" sz="2000" dirty="0">
+                <a:latin typeface="Arial" panose="020B0604020202020204" pitchFamily="34" charset="0"/>
+                <a:cs typeface="Arial" panose="020B0604020202020204" pitchFamily="34" charset="0"/>
+              </a:rPr>
+              <a:t>= </a:t>
+            </a:r>
+            <a:r>
+              <a:rPr lang="en-US" altLang="zh-CN" sz="2000" dirty="0">
+                <a:solidFill>
+                  <a:schemeClr val="accent1"/>
+                </a:solidFill>
+                <a:latin typeface="Arial" panose="020B0604020202020204" pitchFamily="34" charset="0"/>
+                <a:cs typeface="Arial" panose="020B0604020202020204" pitchFamily="34" charset="0"/>
+              </a:rPr>
+              <a:t>not hallucination</a:t>
+            </a:r>
+          </a:p>
+          <a:p>
+            <a:r>
+              <a:rPr lang="en-US" altLang="zh-CN" sz="2000" dirty="0">
+                <a:latin typeface="Arial" panose="020B0604020202020204" pitchFamily="34" charset="0"/>
+                <a:cs typeface="Arial" panose="020B0604020202020204" pitchFamily="34" charset="0"/>
+              </a:rPr>
+              <a:t>unsuccessful repair: </a:t>
+            </a:r>
+            <a:r>
+              <a:rPr lang="en-US" altLang="zh-CN" sz="2000" b="1" dirty="0" err="1">
+                <a:latin typeface="Arial" panose="020B0604020202020204" pitchFamily="34" charset="0"/>
+                <a:cs typeface="Arial" panose="020B0604020202020204" pitchFamily="34" charset="0"/>
+              </a:rPr>
+              <a:t>base_response</a:t>
+            </a:r>
+            <a:r>
+              <a:rPr lang="en-US" altLang="zh-CN" sz="2000" b="1" dirty="0">
+                <a:latin typeface="Arial" panose="020B0604020202020204" pitchFamily="34" charset="0"/>
+                <a:cs typeface="Arial" panose="020B0604020202020204" pitchFamily="34" charset="0"/>
+              </a:rPr>
+              <a:t> </a:t>
+            </a:r>
+            <a:r>
+              <a:rPr lang="en-US" altLang="zh-CN" sz="2000" dirty="0">
+                <a:latin typeface="Arial" panose="020B0604020202020204" pitchFamily="34" charset="0"/>
+                <a:cs typeface="Arial" panose="020B0604020202020204" pitchFamily="34" charset="0"/>
+              </a:rPr>
+              <a:t>= </a:t>
+            </a:r>
+            <a:r>
+              <a:rPr lang="en-US" altLang="zh-CN" sz="2000" dirty="0">
+                <a:solidFill>
+                  <a:srgbClr val="FF0000"/>
+                </a:solidFill>
+                <a:latin typeface="Arial" panose="020B0604020202020204" pitchFamily="34" charset="0"/>
+                <a:cs typeface="Arial" panose="020B0604020202020204" pitchFamily="34" charset="0"/>
+              </a:rPr>
+              <a:t>hallucination</a:t>
+            </a:r>
+            <a:r>
+              <a:rPr lang="en-US" altLang="zh-CN" sz="2000" dirty="0">
+                <a:latin typeface="Arial" panose="020B0604020202020204" pitchFamily="34" charset="0"/>
+                <a:cs typeface="Arial" panose="020B0604020202020204" pitchFamily="34" charset="0"/>
+              </a:rPr>
+              <a:t>, </a:t>
+            </a:r>
+            <a:r>
+              <a:rPr lang="en-US" altLang="zh-CN" sz="2000" b="1" dirty="0" err="1">
+                <a:latin typeface="Arial" panose="020B0604020202020204" pitchFamily="34" charset="0"/>
+                <a:cs typeface="Arial" panose="020B0604020202020204" pitchFamily="34" charset="0"/>
+              </a:rPr>
+              <a:t>final_answer</a:t>
+            </a:r>
+            <a:r>
+              <a:rPr lang="en-US" altLang="zh-CN" sz="2000" dirty="0">
+                <a:latin typeface="Arial" panose="020B0604020202020204" pitchFamily="34" charset="0"/>
+                <a:cs typeface="Arial" panose="020B0604020202020204" pitchFamily="34" charset="0"/>
+              </a:rPr>
+              <a:t> = </a:t>
+            </a:r>
+            <a:r>
+              <a:rPr lang="en-US" altLang="zh-CN" sz="2000" dirty="0">
+                <a:solidFill>
+                  <a:srgbClr val="FF0000"/>
+                </a:solidFill>
+                <a:latin typeface="Arial" panose="020B0604020202020204" pitchFamily="34" charset="0"/>
+                <a:cs typeface="Arial" panose="020B0604020202020204" pitchFamily="34" charset="0"/>
+              </a:rPr>
+              <a:t>hallucination</a:t>
+            </a:r>
+          </a:p>
+          <a:p>
+            <a:r>
+              <a:rPr lang="en-US" altLang="zh-CN" sz="2000" dirty="0">
+                <a:latin typeface="Arial" panose="020B0604020202020204" pitchFamily="34" charset="0"/>
+                <a:cs typeface="Arial" panose="020B0604020202020204" pitchFamily="34" charset="0"/>
+              </a:rPr>
+              <a:t>overcorrection: </a:t>
+            </a:r>
+            <a:r>
+              <a:rPr lang="en-US" altLang="zh-CN" sz="2000" b="1" dirty="0" err="1">
+                <a:latin typeface="Arial" panose="020B0604020202020204" pitchFamily="34" charset="0"/>
+                <a:cs typeface="Arial" panose="020B0604020202020204" pitchFamily="34" charset="0"/>
+              </a:rPr>
+              <a:t>base_response</a:t>
+            </a:r>
+            <a:r>
+              <a:rPr lang="en-US" altLang="zh-CN" sz="2000" b="1" dirty="0">
+                <a:latin typeface="Arial" panose="020B0604020202020204" pitchFamily="34" charset="0"/>
+                <a:cs typeface="Arial" panose="020B0604020202020204" pitchFamily="34" charset="0"/>
+              </a:rPr>
+              <a:t> </a:t>
+            </a:r>
+            <a:r>
+              <a:rPr lang="en-US" altLang="zh-CN" sz="2000" dirty="0">
+                <a:latin typeface="Arial" panose="020B0604020202020204" pitchFamily="34" charset="0"/>
+                <a:cs typeface="Arial" panose="020B0604020202020204" pitchFamily="34" charset="0"/>
+              </a:rPr>
+              <a:t>= </a:t>
+            </a:r>
+            <a:r>
+              <a:rPr lang="en-US" altLang="zh-CN" sz="2000" dirty="0">
+                <a:solidFill>
+                  <a:schemeClr val="accent1"/>
+                </a:solidFill>
+                <a:latin typeface="Arial" panose="020B0604020202020204" pitchFamily="34" charset="0"/>
+                <a:cs typeface="Arial" panose="020B0604020202020204" pitchFamily="34" charset="0"/>
+              </a:rPr>
+              <a:t>not hallucination</a:t>
+            </a:r>
+            <a:r>
+              <a:rPr lang="en-US" altLang="zh-CN" sz="2000" dirty="0">
+                <a:latin typeface="Arial" panose="020B0604020202020204" pitchFamily="34" charset="0"/>
+                <a:cs typeface="Arial" panose="020B0604020202020204" pitchFamily="34" charset="0"/>
+              </a:rPr>
+              <a:t>, </a:t>
+            </a:r>
+            <a:r>
+              <a:rPr lang="en-US" altLang="zh-CN" sz="2000" b="1" dirty="0" err="1">
+                <a:latin typeface="Arial" panose="020B0604020202020204" pitchFamily="34" charset="0"/>
+                <a:cs typeface="Arial" panose="020B0604020202020204" pitchFamily="34" charset="0"/>
+              </a:rPr>
+              <a:t>final_answer</a:t>
+            </a:r>
+            <a:r>
+              <a:rPr lang="en-US" altLang="zh-CN" sz="2000" b="1" dirty="0">
+                <a:latin typeface="Arial" panose="020B0604020202020204" pitchFamily="34" charset="0"/>
+                <a:cs typeface="Arial" panose="020B0604020202020204" pitchFamily="34" charset="0"/>
+              </a:rPr>
+              <a:t> </a:t>
+            </a:r>
+            <a:r>
+              <a:rPr lang="en-US" altLang="zh-CN" sz="2000" dirty="0">
+                <a:latin typeface="Arial" panose="020B0604020202020204" pitchFamily="34" charset="0"/>
+                <a:cs typeface="Arial" panose="020B0604020202020204" pitchFamily="34" charset="0"/>
+              </a:rPr>
+              <a:t>= </a:t>
+            </a:r>
+            <a:r>
+              <a:rPr lang="en-US" altLang="zh-CN" sz="2000" dirty="0">
+                <a:solidFill>
+                  <a:srgbClr val="FF0000"/>
+                </a:solidFill>
+                <a:latin typeface="Arial" panose="020B0604020202020204" pitchFamily="34" charset="0"/>
+                <a:cs typeface="Arial" panose="020B0604020202020204" pitchFamily="34" charset="0"/>
+              </a:rPr>
+              <a:t>hallucination</a:t>
+            </a:r>
+          </a:p>
+          <a:p>
+            <a:r>
+              <a:rPr lang="en-US" altLang="zh-CN" sz="2000" dirty="0">
+                <a:latin typeface="Arial" panose="020B0604020202020204" pitchFamily="34" charset="0"/>
+                <a:cs typeface="Arial" panose="020B0604020202020204" pitchFamily="34" charset="0"/>
+              </a:rPr>
+              <a:t>pass@6: at least 1 is correct in the checking results of (mutations + </a:t>
+            </a:r>
+            <a:r>
+              <a:rPr lang="en-US" altLang="zh-CN" sz="2000" dirty="0" err="1">
+                <a:latin typeface="Arial" panose="020B0604020202020204" pitchFamily="34" charset="0"/>
+                <a:cs typeface="Arial" panose="020B0604020202020204" pitchFamily="34" charset="0"/>
+              </a:rPr>
+              <a:t>base_response</a:t>
+            </a:r>
+            <a:r>
+              <a:rPr lang="en-US" altLang="zh-CN" sz="2000" dirty="0">
+                <a:latin typeface="Arial" panose="020B0604020202020204" pitchFamily="34" charset="0"/>
+                <a:cs typeface="Arial" panose="020B0604020202020204" pitchFamily="34" charset="0"/>
+              </a:rPr>
+              <a:t>)</a:t>
+            </a:r>
+          </a:p>
+          <a:p>
+            <a:r>
+              <a:rPr lang="en-US" altLang="zh-CN" sz="2000" dirty="0">
+                <a:latin typeface="Arial" panose="020B0604020202020204" pitchFamily="34" charset="0"/>
+                <a:cs typeface="Arial" panose="020B0604020202020204" pitchFamily="34" charset="0"/>
+              </a:rPr>
+              <a:t>avg token cost pre question</a:t>
+            </a:r>
+          </a:p>
+          <a:p>
+            <a:r>
+              <a:rPr lang="en-US" altLang="zh-CN" sz="2000" dirty="0">
+                <a:latin typeface="Arial" panose="020B0604020202020204" pitchFamily="34" charset="0"/>
+                <a:cs typeface="Arial" panose="020B0604020202020204" pitchFamily="34" charset="0"/>
+              </a:rPr>
+              <a:t>avg time cost pre question</a:t>
+            </a:r>
+          </a:p>
+          <a:p>
+            <a:endParaRPr lang="en-US" altLang="zh-CN" sz="2000" dirty="0">
+              <a:latin typeface="Arial" panose="020B0604020202020204" pitchFamily="34" charset="0"/>
+              <a:cs typeface="Arial" panose="020B0604020202020204" pitchFamily="34" charset="0"/>
+            </a:endParaRPr>
+          </a:p>
+          <a:p>
+            <a:r>
+              <a:rPr lang="en-US" altLang="zh-CN" sz="2400" b="1" dirty="0">
+                <a:latin typeface="Arial" panose="020B0604020202020204" pitchFamily="34" charset="0"/>
+                <a:cs typeface="Arial" panose="020B0604020202020204" pitchFamily="34" charset="0"/>
+              </a:rPr>
+              <a:t>Number of mutations: </a:t>
+            </a:r>
+            <a:r>
+              <a:rPr lang="en-US" altLang="zh-CN" sz="2000" dirty="0">
+                <a:latin typeface="Arial" panose="020B0604020202020204" pitchFamily="34" charset="0"/>
+                <a:cs typeface="Arial" panose="020B0604020202020204" pitchFamily="34" charset="0"/>
+              </a:rPr>
+              <a:t>5(synonym)</a:t>
+            </a:r>
+          </a:p>
+        </p:txBody>
+      </p:sp>
+    </p:spTree>
+    <p:extLst>
+      <p:ext uri="{BB962C8B-B14F-4D97-AF65-F5344CB8AC3E}">
+        <p14:creationId xmlns:p14="http://schemas.microsoft.com/office/powerpoint/2010/main" val="947931490"/>
+      </p:ext>
+    </p:extLst>
+  </p:cSld>
+  <p:clrMapOvr>
+    <a:masterClrMapping/>
+  </p:clrMapOvr>
+</p:sld>
+</file>
+
+<file path=ppt/slides/slide6.xml><?xml version="1.0" encoding="utf-8"?>
+<p:sld xmlns:a="http://schemas.openxmlformats.org/drawingml/2006/main" xmlns:r="http://schemas.openxmlformats.org/officeDocument/2006/relationships" xmlns:p="http://schemas.openxmlformats.org/presentationml/2006/main">
+  <p:cSld>
+    <p:spTree>
+      <p:nvGrpSpPr>
+        <p:cNvPr id="1" name=""/>
+        <p:cNvGrpSpPr/>
+        <p:nvPr/>
+      </p:nvGrpSpPr>
+      <p:grpSpPr>
+        <a:xfrm>
+          <a:off x="0" y="0"/>
+          <a:ext cx="0" cy="0"/>
+          <a:chOff x="0" y="0"/>
+          <a:chExt cx="0" cy="0"/>
+        </a:xfrm>
+      </p:grpSpPr>
+      <p:sp>
+        <p:nvSpPr>
           <p:cNvPr id="7" name="文本框 6">
             <a:extLst>
               <a:ext uri="{FF2B5EF4-FFF2-40B4-BE49-F238E27FC236}">
@@ -4343,10 +4743,10 @@
       </p:sp>
       <p:pic>
         <p:nvPicPr>
-          <p:cNvPr id="8" name="图片 7">
-            <a:extLst>
-              <a:ext uri="{FF2B5EF4-FFF2-40B4-BE49-F238E27FC236}">
-                <a16:creationId xmlns:a16="http://schemas.microsoft.com/office/drawing/2014/main" id="{31E232DD-5FD8-DC15-2536-136BBE4BDD4C}"/>
+          <p:cNvPr id="3" name="图片 2" descr="图表, 条形图&#10;&#10;AI 生成的内容可能不正确。">
+            <a:extLst>
+              <a:ext uri="{FF2B5EF4-FFF2-40B4-BE49-F238E27FC236}">
+                <a16:creationId xmlns:a16="http://schemas.microsoft.com/office/drawing/2014/main" id="{C65C1D66-193D-79BA-CF43-0D5364B3D088}"/>
               </a:ext>
             </a:extLst>
           </p:cNvPr>
@@ -4363,7 +4763,7 @@
         </p:blipFill>
         <p:spPr>
           <a:xfrm>
-            <a:off x="6504132" y="735954"/>
+            <a:off x="6504131" y="735954"/>
             <a:ext cx="4785360" cy="5189220"/>
           </a:xfrm>
           <a:prstGeom prst="rect">
@@ -4373,10 +4773,10 @@
       </p:pic>
       <p:pic>
         <p:nvPicPr>
-          <p:cNvPr id="12" name="图片 11">
-            <a:extLst>
-              <a:ext uri="{FF2B5EF4-FFF2-40B4-BE49-F238E27FC236}">
-                <a16:creationId xmlns:a16="http://schemas.microsoft.com/office/drawing/2014/main" id="{CD103B4E-D539-F2FC-F6FF-ED1C249F76EC}"/>
+          <p:cNvPr id="5" name="图片 4" descr="图表, 条形图&#10;&#10;AI 生成的内容可能不正确。">
+            <a:extLst>
+              <a:ext uri="{FF2B5EF4-FFF2-40B4-BE49-F238E27FC236}">
+                <a16:creationId xmlns:a16="http://schemas.microsoft.com/office/drawing/2014/main" id="{C764A6F0-E9E5-80EB-4513-C09E818350A4}"/>
               </a:ext>
             </a:extLst>
           </p:cNvPr>
@@ -4414,7 +4814,7 @@
 </p:sld>
 </file>
 
-<file path=ppt/slides/slide5.xml><?xml version="1.0" encoding="utf-8"?>
+<file path=ppt/slides/slide7.xml><?xml version="1.0" encoding="utf-8"?>
 <p:sld xmlns:a="http://schemas.openxmlformats.org/drawingml/2006/main" xmlns:r="http://schemas.openxmlformats.org/officeDocument/2006/relationships" xmlns:p="http://schemas.openxmlformats.org/presentationml/2006/main">
   <p:cSld>
     <p:spTree>
@@ -4452,14 +4852,14 @@
           <p:nvPr>
             <p:extLst>
               <p:ext uri="{D42A27DB-BD31-4B8C-83A1-F6EECF244321}">
-                <p14:modId xmlns:p14="http://schemas.microsoft.com/office/powerpoint/2010/main" val="3871858807"/>
+                <p14:modId xmlns:p14="http://schemas.microsoft.com/office/powerpoint/2010/main" val="3625531032"/>
               </p:ext>
             </p:extLst>
           </p:nvPr>
         </p:nvGraphicFramePr>
         <p:xfrm>
-          <a:off x="6096000" y="735954"/>
-          <a:ext cx="5948220" cy="1283435"/>
+          <a:off x="5473609" y="735954"/>
+          <a:ext cx="6238673" cy="1283435"/>
         </p:xfrm>
         <a:graphic>
           <a:graphicData uri="http://schemas.openxmlformats.org/drawingml/2006/table">
@@ -4468,45 +4868,52 @@
                 <a:tableStyleId>{5C22544A-7EE6-4342-B048-85BDC9FD1C3A}</a:tableStyleId>
               </a:tblPr>
               <a:tblGrid>
-                <a:gridCol w="991370">
+                <a:gridCol w="891239">
                   <a:extLst>
                     <a:ext uri="{9D8B030D-6E8A-4147-A177-3AD203B41FA5}">
                       <a16:colId xmlns:a16="http://schemas.microsoft.com/office/drawing/2014/main" val="4101249701"/>
                     </a:ext>
                   </a:extLst>
                 </a:gridCol>
-                <a:gridCol w="991370">
+                <a:gridCol w="891239">
                   <a:extLst>
                     <a:ext uri="{9D8B030D-6E8A-4147-A177-3AD203B41FA5}">
                       <a16:colId xmlns:a16="http://schemas.microsoft.com/office/drawing/2014/main" val="64436008"/>
                     </a:ext>
                   </a:extLst>
                 </a:gridCol>
-                <a:gridCol w="991370">
+                <a:gridCol w="891239">
                   <a:extLst>
                     <a:ext uri="{9D8B030D-6E8A-4147-A177-3AD203B41FA5}">
                       <a16:colId xmlns:a16="http://schemas.microsoft.com/office/drawing/2014/main" val="2870068380"/>
                     </a:ext>
                   </a:extLst>
                 </a:gridCol>
-                <a:gridCol w="991370">
+                <a:gridCol w="891239">
                   <a:extLst>
                     <a:ext uri="{9D8B030D-6E8A-4147-A177-3AD203B41FA5}">
                       <a16:colId xmlns:a16="http://schemas.microsoft.com/office/drawing/2014/main" val="2903000029"/>
                     </a:ext>
                   </a:extLst>
                 </a:gridCol>
-                <a:gridCol w="991370">
+                <a:gridCol w="891239">
                   <a:extLst>
                     <a:ext uri="{9D8B030D-6E8A-4147-A177-3AD203B41FA5}">
                       <a16:colId xmlns:a16="http://schemas.microsoft.com/office/drawing/2014/main" val="3141391406"/>
                     </a:ext>
                   </a:extLst>
                 </a:gridCol>
-                <a:gridCol w="991370">
+                <a:gridCol w="891239">
                   <a:extLst>
                     <a:ext uri="{9D8B030D-6E8A-4147-A177-3AD203B41FA5}">
                       <a16:colId xmlns:a16="http://schemas.microsoft.com/office/drawing/2014/main" val="1620127239"/>
+                    </a:ext>
+                  </a:extLst>
+                </a:gridCol>
+                <a:gridCol w="891239">
+                  <a:extLst>
+                    <a:ext uri="{9D8B030D-6E8A-4147-A177-3AD203B41FA5}">
+                      <a16:colId xmlns:a16="http://schemas.microsoft.com/office/drawing/2014/main" val="2425524162"/>
                     </a:ext>
                   </a:extLst>
                 </a:gridCol>
@@ -4556,12 +4963,28 @@
                         <a:defRPr/>
                       </a:pPr>
                       <a:r>
-                        <a:rPr lang="en-US" altLang="zh-CN" sz="1200">
+                        <a:rPr lang="en-US" altLang="zh-CN" sz="1200" dirty="0">
                           <a:latin typeface="Calibri" panose="020F0502020204030204" pitchFamily="34" charset="0"/>
                           <a:ea typeface="Calibri" panose="020F0502020204030204" pitchFamily="34" charset="0"/>
                           <a:cs typeface="Calibri" panose="020F0502020204030204" pitchFamily="34" charset="0"/>
                         </a:rPr>
-                        <a:t>Chain-of-Thought (CoT)</a:t>
+                        <a:t>Chain-of-Thought (</a:t>
+                      </a:r>
+                      <a:r>
+                        <a:rPr lang="en-US" altLang="zh-CN" sz="1200" dirty="0" err="1">
+                          <a:latin typeface="Calibri" panose="020F0502020204030204" pitchFamily="34" charset="0"/>
+                          <a:ea typeface="Calibri" panose="020F0502020204030204" pitchFamily="34" charset="0"/>
+                          <a:cs typeface="Calibri" panose="020F0502020204030204" pitchFamily="34" charset="0"/>
+                        </a:rPr>
+                        <a:t>CoT</a:t>
+                      </a:r>
+                      <a:r>
+                        <a:rPr lang="en-US" altLang="zh-CN" sz="1200" dirty="0">
+                          <a:latin typeface="Calibri" panose="020F0502020204030204" pitchFamily="34" charset="0"/>
+                          <a:ea typeface="Calibri" panose="020F0502020204030204" pitchFamily="34" charset="0"/>
+                          <a:cs typeface="Calibri" panose="020F0502020204030204" pitchFamily="34" charset="0"/>
+                        </a:rPr>
+                        <a:t>)</a:t>
                       </a:r>
                       <a:endParaRPr lang="zh-CN" altLang="en-US" sz="1200" dirty="0">
                         <a:latin typeface="Calibri" panose="020F0502020204030204" pitchFamily="34" charset="0"/>
@@ -4708,7 +5131,7 @@
                         <a:defRPr/>
                       </a:pPr>
                       <a:r>
-                        <a:rPr lang="en-US" altLang="zh-CN" sz="1200">
+                        <a:rPr lang="en-US" altLang="zh-CN" sz="1200" dirty="0">
                           <a:latin typeface="Calibri" panose="020F0502020204030204" pitchFamily="34" charset="0"/>
                           <a:ea typeface="Calibri" panose="020F0502020204030204" pitchFamily="34" charset="0"/>
                           <a:cs typeface="Calibri" panose="020F0502020204030204" pitchFamily="34" charset="0"/>
@@ -4716,19 +5139,56 @@
                         <a:t>our approach</a:t>
                       </a:r>
                       <a:r>
-                        <a:rPr lang="zh-CN" altLang="en-US" sz="1200">
+                        <a:rPr lang="zh-CN" altLang="en-US" sz="1200" dirty="0">
                           <a:latin typeface="Calibri" panose="020F0502020204030204" pitchFamily="34" charset="0"/>
                           <a:cs typeface="Calibri" panose="020F0502020204030204" pitchFamily="34" charset="0"/>
                         </a:rPr>
                         <a:t> </a:t>
                       </a:r>
                       <a:r>
-                        <a:rPr lang="en-US" altLang="zh-CN" sz="1200">
+                        <a:rPr lang="en-US" altLang="zh-CN" sz="1200" dirty="0">
                           <a:latin typeface="Calibri" panose="020F0502020204030204" pitchFamily="34" charset="0"/>
                           <a:ea typeface="Calibri" panose="020F0502020204030204" pitchFamily="34" charset="0"/>
                           <a:cs typeface="Calibri" panose="020F0502020204030204" pitchFamily="34" charset="0"/>
                         </a:rPr>
                         <a:t>- mutations</a:t>
+                      </a:r>
+                      <a:endParaRPr lang="zh-CN" altLang="en-US" sz="1200" dirty="0">
+                        <a:latin typeface="Calibri" panose="020F0502020204030204" pitchFamily="34" charset="0"/>
+                        <a:cs typeface="Calibri" panose="020F0502020204030204" pitchFamily="34" charset="0"/>
+                      </a:endParaRPr>
+                    </a:p>
+                  </a:txBody>
+                  <a:tcPr/>
+                </a:tc>
+                <a:tc>
+                  <a:txBody>
+                    <a:bodyPr/>
+                    <a:lstStyle/>
+                    <a:p>
+                      <a:pPr marL="0" marR="0" lvl="0" indent="0" algn="l" defTabSz="914400" rtl="0" eaLnBrk="1" fontAlgn="auto" latinLnBrk="0" hangingPunct="1">
+                        <a:lnSpc>
+                          <a:spcPct val="100000"/>
+                        </a:lnSpc>
+                        <a:spcBef>
+                          <a:spcPts val="0"/>
+                        </a:spcBef>
+                        <a:spcAft>
+                          <a:spcPts val="0"/>
+                        </a:spcAft>
+                        <a:buClrTx/>
+                        <a:buSzTx/>
+                        <a:buFontTx/>
+                        <a:buNone/>
+                        <a:tabLst/>
+                        <a:defRPr/>
+                      </a:pPr>
+                      <a:r>
+                        <a:rPr lang="en-US" altLang="zh-CN" sz="1200" dirty="0">
+                          <a:latin typeface="Calibri" panose="020F0502020204030204" pitchFamily="34" charset="0"/>
+                          <a:cs typeface="Calibri" panose="020F0502020204030204" pitchFamily="34" charset="0"/>
+                        </a:rPr>
+                        <a:t>our approach - vs</a:t>
                       </a:r>
                       <a:endParaRPr lang="zh-CN" altLang="en-US" sz="1200" dirty="0">
                         <a:latin typeface="Calibri" panose="020F0502020204030204" pitchFamily="34" charset="0"/>
@@ -4871,6 +5331,27 @@
                   </a:txBody>
                   <a:tcPr/>
                 </a:tc>
+                <a:tc>
+                  <a:txBody>
+                    <a:bodyPr/>
+                    <a:lstStyle/>
+                    <a:p>
+                      <a:pPr algn="ctr"/>
+                      <a:r>
+                        <a:rPr lang="en-US" altLang="zh-CN" sz="1400" dirty="0">
+                          <a:latin typeface="Arial" panose="020B0604020202020204" pitchFamily="34" charset="0"/>
+                          <a:cs typeface="Arial" panose="020B0604020202020204" pitchFamily="34" charset="0"/>
+                        </a:rPr>
+                        <a:t>596.13</a:t>
+                      </a:r>
+                      <a:endParaRPr lang="zh-CN" altLang="en-US" sz="1400" dirty="0">
+                        <a:latin typeface="Arial" panose="020B0604020202020204" pitchFamily="34" charset="0"/>
+                        <a:cs typeface="Arial" panose="020B0604020202020204" pitchFamily="34" charset="0"/>
+                      </a:endParaRPr>
+                    </a:p>
+                  </a:txBody>
+                  <a:tcPr/>
+                </a:tc>
                 <a:extLst>
                   <a:ext uri="{0D108BD9-81ED-4DB2-BD59-A6C34878D82A}">
                     <a16:rowId xmlns:a16="http://schemas.microsoft.com/office/drawing/2014/main" val="971162633"/>
@@ -4884,6 +5365,55 @@
                     <a:lstStyle/>
                     <a:p>
                       <a:pPr algn="ctr"/>
+                      <a:r>
+                        <a:rPr lang="en-US" altLang="zh-CN" sz="1400" dirty="0">
+                          <a:latin typeface="Arial" panose="020B0604020202020204" pitchFamily="34" charset="0"/>
+                          <a:cs typeface="Arial" panose="020B0604020202020204" pitchFamily="34" charset="0"/>
+                        </a:rPr>
+                        <a:t>gpt-5</a:t>
+                      </a:r>
+                      <a:endParaRPr lang="zh-CN" altLang="en-US" sz="1400" dirty="0">
+                        <a:latin typeface="Arial" panose="020B0604020202020204" pitchFamily="34" charset="0"/>
+                        <a:cs typeface="Arial" panose="020B0604020202020204" pitchFamily="34" charset="0"/>
+                      </a:endParaRPr>
+                    </a:p>
+                  </a:txBody>
+                  <a:tcPr/>
+                </a:tc>
+                <a:tc>
+                  <a:txBody>
+                    <a:bodyPr/>
+                    <a:lstStyle/>
+                    <a:p>
+                      <a:pPr algn="ctr"/>
+                      <a:r>
+                        <a:rPr lang="en-US" altLang="zh-CN" sz="1400" dirty="0">
+                          <a:latin typeface="Arial" panose="020B0604020202020204" pitchFamily="34" charset="0"/>
+                          <a:cs typeface="Arial" panose="020B0604020202020204" pitchFamily="34" charset="0"/>
+                        </a:rPr>
+                        <a:t>87.03</a:t>
+                      </a:r>
+                      <a:endParaRPr lang="zh-CN" altLang="en-US" sz="1400" dirty="0">
+                        <a:latin typeface="Arial" panose="020B0604020202020204" pitchFamily="34" charset="0"/>
+                        <a:cs typeface="Arial" panose="020B0604020202020204" pitchFamily="34" charset="0"/>
+                      </a:endParaRPr>
+                    </a:p>
+                  </a:txBody>
+                  <a:tcPr/>
+                </a:tc>
+                <a:tc>
+                  <a:txBody>
+                    <a:bodyPr/>
+                    <a:lstStyle/>
+                    <a:p>
+                      <a:pPr algn="ctr"/>
+                      <a:r>
+                        <a:rPr lang="en-US" altLang="zh-CN" sz="1400" dirty="0">
+                          <a:latin typeface="Arial" panose="020B0604020202020204" pitchFamily="34" charset="0"/>
+                          <a:cs typeface="Arial" panose="020B0604020202020204" pitchFamily="34" charset="0"/>
+                        </a:rPr>
+                        <a:t>6824.61</a:t>
+                      </a:r>
                       <a:endParaRPr lang="zh-CN" altLang="en-US" sz="1400" dirty="0">
                         <a:latin typeface="Arial" panose="020B0604020202020204" pitchFamily="34" charset="0"/>
                         <a:cs typeface="Arial" panose="020B0604020202020204" pitchFamily="34" charset="0"/>
@@ -4912,6 +5442,13 @@
                     <a:lstStyle/>
                     <a:p>
                       <a:pPr algn="ctr"/>
+                      <a:r>
+                        <a:rPr lang="en-US" altLang="zh-CN" sz="1400" dirty="0">
+                          <a:latin typeface="Arial" panose="020B0604020202020204" pitchFamily="34" charset="0"/>
+                          <a:cs typeface="Arial" panose="020B0604020202020204" pitchFamily="34" charset="0"/>
+                        </a:rPr>
+                        <a:t>188.51</a:t>
+                      </a:r>
                       <a:endParaRPr lang="zh-CN" altLang="en-US" sz="1400" dirty="0">
                         <a:latin typeface="Arial" panose="020B0604020202020204" pitchFamily="34" charset="0"/>
                         <a:cs typeface="Arial" panose="020B0604020202020204" pitchFamily="34" charset="0"/>
@@ -4926,6 +5463,13 @@
                     <a:lstStyle/>
                     <a:p>
                       <a:pPr algn="ctr"/>
+                      <a:r>
+                        <a:rPr lang="en-US" altLang="zh-CN" sz="1400" dirty="0">
+                          <a:latin typeface="Arial" panose="020B0604020202020204" pitchFamily="34" charset="0"/>
+                          <a:cs typeface="Arial" panose="020B0604020202020204" pitchFamily="34" charset="0"/>
+                        </a:rPr>
+                        <a:t>1775.89</a:t>
+                      </a:r>
                       <a:endParaRPr lang="zh-CN" altLang="en-US" sz="1400" dirty="0">
                         <a:latin typeface="Arial" panose="020B0604020202020204" pitchFamily="34" charset="0"/>
                         <a:cs typeface="Arial" panose="020B0604020202020204" pitchFamily="34" charset="0"/>
@@ -4940,20 +5484,13 @@
                     <a:lstStyle/>
                     <a:p>
                       <a:pPr algn="ctr"/>
-                      <a:endParaRPr lang="zh-CN" altLang="en-US" sz="1400" dirty="0">
-                        <a:latin typeface="Arial" panose="020B0604020202020204" pitchFamily="34" charset="0"/>
-                        <a:cs typeface="Arial" panose="020B0604020202020204" pitchFamily="34" charset="0"/>
-                      </a:endParaRPr>
-                    </a:p>
-                  </a:txBody>
-                  <a:tcPr/>
-                </a:tc>
-                <a:tc>
-                  <a:txBody>
-                    <a:bodyPr/>
-                    <a:lstStyle/>
-                    <a:p>
-                      <a:pPr algn="ctr"/>
+                      <a:r>
+                        <a:rPr lang="en-US" altLang="zh-CN" sz="1400" dirty="0">
+                          <a:latin typeface="Arial" panose="020B0604020202020204" pitchFamily="34" charset="0"/>
+                          <a:cs typeface="Arial" panose="020B0604020202020204" pitchFamily="34" charset="0"/>
+                        </a:rPr>
+                        <a:t>580.05</a:t>
+                      </a:r>
                       <a:endParaRPr lang="zh-CN" altLang="en-US" sz="1400" dirty="0">
                         <a:latin typeface="Arial" panose="020B0604020202020204" pitchFamily="34" charset="0"/>
                         <a:cs typeface="Arial" panose="020B0604020202020204" pitchFamily="34" charset="0"/>
@@ -4987,14 +5524,14 @@
           <p:nvPr>
             <p:extLst>
               <p:ext uri="{D42A27DB-BD31-4B8C-83A1-F6EECF244321}">
-                <p14:modId xmlns:p14="http://schemas.microsoft.com/office/powerpoint/2010/main" val="5200815"/>
+                <p14:modId xmlns:p14="http://schemas.microsoft.com/office/powerpoint/2010/main" val="1585966000"/>
               </p:ext>
             </p:extLst>
           </p:nvPr>
         </p:nvGraphicFramePr>
         <p:xfrm>
-          <a:off x="6096000" y="2019389"/>
-          <a:ext cx="5948220" cy="1276241"/>
+          <a:off x="5473609" y="2019389"/>
+          <a:ext cx="6225331" cy="1276241"/>
         </p:xfrm>
         <a:graphic>
           <a:graphicData uri="http://schemas.openxmlformats.org/drawingml/2006/table">
@@ -5003,45 +5540,52 @@
                 <a:tableStyleId>{5C22544A-7EE6-4342-B048-85BDC9FD1C3A}</a:tableStyleId>
               </a:tblPr>
               <a:tblGrid>
-                <a:gridCol w="991370">
+                <a:gridCol w="889333">
                   <a:extLst>
                     <a:ext uri="{9D8B030D-6E8A-4147-A177-3AD203B41FA5}">
                       <a16:colId xmlns:a16="http://schemas.microsoft.com/office/drawing/2014/main" val="4101249701"/>
                     </a:ext>
                   </a:extLst>
                 </a:gridCol>
-                <a:gridCol w="991370">
+                <a:gridCol w="889333">
                   <a:extLst>
                     <a:ext uri="{9D8B030D-6E8A-4147-A177-3AD203B41FA5}">
                       <a16:colId xmlns:a16="http://schemas.microsoft.com/office/drawing/2014/main" val="64436008"/>
                     </a:ext>
                   </a:extLst>
                 </a:gridCol>
-                <a:gridCol w="991370">
+                <a:gridCol w="889333">
                   <a:extLst>
                     <a:ext uri="{9D8B030D-6E8A-4147-A177-3AD203B41FA5}">
                       <a16:colId xmlns:a16="http://schemas.microsoft.com/office/drawing/2014/main" val="2870068380"/>
                     </a:ext>
                   </a:extLst>
                 </a:gridCol>
-                <a:gridCol w="991370">
+                <a:gridCol w="889333">
                   <a:extLst>
                     <a:ext uri="{9D8B030D-6E8A-4147-A177-3AD203B41FA5}">
                       <a16:colId xmlns:a16="http://schemas.microsoft.com/office/drawing/2014/main" val="2903000029"/>
                     </a:ext>
                   </a:extLst>
                 </a:gridCol>
-                <a:gridCol w="991370">
+                <a:gridCol w="889333">
                   <a:extLst>
                     <a:ext uri="{9D8B030D-6E8A-4147-A177-3AD203B41FA5}">
                       <a16:colId xmlns:a16="http://schemas.microsoft.com/office/drawing/2014/main" val="3141391406"/>
                     </a:ext>
                   </a:extLst>
                 </a:gridCol>
-                <a:gridCol w="991370">
+                <a:gridCol w="889333">
                   <a:extLst>
                     <a:ext uri="{9D8B030D-6E8A-4147-A177-3AD203B41FA5}">
                       <a16:colId xmlns:a16="http://schemas.microsoft.com/office/drawing/2014/main" val="4228366896"/>
+                    </a:ext>
+                  </a:extLst>
+                </a:gridCol>
+                <a:gridCol w="889333">
+                  <a:extLst>
+                    <a:ext uri="{9D8B030D-6E8A-4147-A177-3AD203B41FA5}">
+                      <a16:colId xmlns:a16="http://schemas.microsoft.com/office/drawing/2014/main" val="3963888700"/>
                     </a:ext>
                   </a:extLst>
                 </a:gridCol>
@@ -5330,6 +5874,43 @@
                   </a:txBody>
                   <a:tcPr/>
                 </a:tc>
+                <a:tc>
+                  <a:txBody>
+                    <a:bodyPr/>
+                    <a:lstStyle/>
+                    <a:p>
+                      <a:pPr marL="0" marR="0" lvl="0" indent="0" algn="l" defTabSz="914400" rtl="0" eaLnBrk="1" fontAlgn="auto" latinLnBrk="0" hangingPunct="1">
+                        <a:lnSpc>
+                          <a:spcPct val="100000"/>
+                        </a:lnSpc>
+                        <a:spcBef>
+                          <a:spcPts val="0"/>
+                        </a:spcBef>
+                        <a:spcAft>
+                          <a:spcPts val="0"/>
+                        </a:spcAft>
+                        <a:buClrTx/>
+                        <a:buSzTx/>
+                        <a:buFontTx/>
+                        <a:buNone/>
+                        <a:tabLst/>
+                        <a:defRPr/>
+                      </a:pPr>
+                      <a:r>
+                        <a:rPr lang="en-US" altLang="zh-CN" sz="1200" dirty="0">
+                          <a:latin typeface="Calibri" panose="020F0502020204030204" pitchFamily="34" charset="0"/>
+                          <a:cs typeface="Calibri" panose="020F0502020204030204" pitchFamily="34" charset="0"/>
+                        </a:rPr>
+                        <a:t>our approach - vs</a:t>
+                      </a:r>
+                      <a:endParaRPr lang="zh-CN" altLang="en-US" sz="1200" dirty="0">
+                        <a:latin typeface="Calibri" panose="020F0502020204030204" pitchFamily="34" charset="0"/>
+                        <a:cs typeface="Calibri" panose="020F0502020204030204" pitchFamily="34" charset="0"/>
+                      </a:endParaRPr>
+                    </a:p>
+                  </a:txBody>
+                  <a:tcPr/>
+                </a:tc>
                 <a:extLst>
                   <a:ext uri="{0D108BD9-81ED-4DB2-BD59-A6C34878D82A}">
                     <a16:rowId xmlns:a16="http://schemas.microsoft.com/office/drawing/2014/main" val="3466647714"/>
@@ -5459,6 +6040,27 @@
                   </a:txBody>
                   <a:tcPr/>
                 </a:tc>
+                <a:tc>
+                  <a:txBody>
+                    <a:bodyPr/>
+                    <a:lstStyle/>
+                    <a:p>
+                      <a:pPr algn="ctr"/>
+                      <a:r>
+                        <a:rPr lang="en-US" altLang="zh-CN" sz="1400" dirty="0">
+                          <a:latin typeface="Arial" panose="020B0604020202020204" pitchFamily="34" charset="0"/>
+                          <a:cs typeface="Arial" panose="020B0604020202020204" pitchFamily="34" charset="0"/>
+                        </a:rPr>
+                        <a:t>4.4483</a:t>
+                      </a:r>
+                      <a:endParaRPr lang="zh-CN" altLang="en-US" sz="1400" dirty="0">
+                        <a:latin typeface="Arial" panose="020B0604020202020204" pitchFamily="34" charset="0"/>
+                        <a:cs typeface="Arial" panose="020B0604020202020204" pitchFamily="34" charset="0"/>
+                      </a:endParaRPr>
+                    </a:p>
+                  </a:txBody>
+                  <a:tcPr/>
+                </a:tc>
                 <a:extLst>
                   <a:ext uri="{0D108BD9-81ED-4DB2-BD59-A6C34878D82A}">
                     <a16:rowId xmlns:a16="http://schemas.microsoft.com/office/drawing/2014/main" val="971162633"/>
@@ -5472,6 +6074,13 @@
                     <a:lstStyle/>
                     <a:p>
                       <a:pPr algn="ctr"/>
+                      <a:r>
+                        <a:rPr lang="en-US" altLang="zh-CN" sz="1400" dirty="0">
+                          <a:latin typeface="Arial" panose="020B0604020202020204" pitchFamily="34" charset="0"/>
+                          <a:cs typeface="Arial" panose="020B0604020202020204" pitchFamily="34" charset="0"/>
+                        </a:rPr>
+                        <a:t>gpt-5</a:t>
+                      </a:r>
                       <a:endParaRPr lang="zh-CN" altLang="en-US" sz="1400" dirty="0">
                         <a:latin typeface="Arial" panose="020B0604020202020204" pitchFamily="34" charset="0"/>
                         <a:cs typeface="Arial" panose="020B0604020202020204" pitchFamily="34" charset="0"/>
@@ -5502,6 +6111,34 @@
                         <a:tabLst/>
                         <a:defRPr/>
                       </a:pPr>
+                      <a:r>
+                        <a:rPr lang="en-US" altLang="zh-CN" sz="1400" dirty="0">
+                          <a:latin typeface="Arial" panose="020B0604020202020204" pitchFamily="34" charset="0"/>
+                          <a:cs typeface="Arial" panose="020B0604020202020204" pitchFamily="34" charset="0"/>
+                        </a:rPr>
+                        <a:t>12.4434</a:t>
+                      </a:r>
+                      <a:endParaRPr lang="zh-CN" altLang="en-US" sz="1400" dirty="0">
+                        <a:latin typeface="Arial" panose="020B0604020202020204" pitchFamily="34" charset="0"/>
+                        <a:cs typeface="Arial" panose="020B0604020202020204" pitchFamily="34" charset="0"/>
+                      </a:endParaRPr>
+                    </a:p>
+                  </a:txBody>
+                  <a:tcPr/>
+                </a:tc>
+                <a:tc>
+                  <a:txBody>
+                    <a:bodyPr/>
+                    <a:lstStyle/>
+                    <a:p>
+                      <a:pPr algn="ctr"/>
+                      <a:r>
+                        <a:rPr lang="en-US" altLang="zh-CN" sz="1400" dirty="0">
+                          <a:latin typeface="Arial" panose="020B0604020202020204" pitchFamily="34" charset="0"/>
+                          <a:cs typeface="Arial" panose="020B0604020202020204" pitchFamily="34" charset="0"/>
+                        </a:rPr>
+                        <a:t>202.180</a:t>
+                      </a:r>
                       <a:endParaRPr lang="zh-CN" altLang="en-US" sz="1400" dirty="0">
                         <a:latin typeface="Arial" panose="020B0604020202020204" pitchFamily="34" charset="0"/>
                         <a:cs typeface="Arial" panose="020B0604020202020204" pitchFamily="34" charset="0"/>
@@ -5530,6 +6167,13 @@
                     <a:lstStyle/>
                     <a:p>
                       <a:pPr algn="ctr"/>
+                      <a:r>
+                        <a:rPr lang="en-US" altLang="zh-CN" sz="1400" dirty="0">
+                          <a:latin typeface="Arial" panose="020B0604020202020204" pitchFamily="34" charset="0"/>
+                          <a:cs typeface="Arial" panose="020B0604020202020204" pitchFamily="34" charset="0"/>
+                        </a:rPr>
+                        <a:t>21.4348</a:t>
+                      </a:r>
                       <a:endParaRPr lang="zh-CN" altLang="en-US" sz="1400" dirty="0">
                         <a:latin typeface="Arial" panose="020B0604020202020204" pitchFamily="34" charset="0"/>
                         <a:cs typeface="Arial" panose="020B0604020202020204" pitchFamily="34" charset="0"/>
@@ -5544,6 +6188,13 @@
                     <a:lstStyle/>
                     <a:p>
                       <a:pPr algn="ctr"/>
+                      <a:r>
+                        <a:rPr lang="en-US" altLang="zh-CN" sz="1400" dirty="0">
+                          <a:latin typeface="Arial" panose="020B0604020202020204" pitchFamily="34" charset="0"/>
+                          <a:cs typeface="Arial" panose="020B0604020202020204" pitchFamily="34" charset="0"/>
+                        </a:rPr>
+                        <a:t>187.810</a:t>
+                      </a:r>
                       <a:endParaRPr lang="zh-CN" altLang="en-US" sz="1400" dirty="0">
                         <a:latin typeface="Arial" panose="020B0604020202020204" pitchFamily="34" charset="0"/>
                         <a:cs typeface="Arial" panose="020B0604020202020204" pitchFamily="34" charset="0"/>
@@ -5558,6 +6209,13 @@
                     <a:lstStyle/>
                     <a:p>
                       <a:pPr algn="ctr"/>
+                      <a:r>
+                        <a:rPr lang="en-US" altLang="zh-CN" sz="1400" dirty="0">
+                          <a:latin typeface="Arial" panose="020B0604020202020204" pitchFamily="34" charset="0"/>
+                          <a:cs typeface="Arial" panose="020B0604020202020204" pitchFamily="34" charset="0"/>
+                        </a:rPr>
+                        <a:t>36.9961</a:t>
+                      </a:r>
                       <a:endParaRPr lang="zh-CN" altLang="en-US" sz="1400" dirty="0">
                         <a:latin typeface="Arial" panose="020B0604020202020204" pitchFamily="34" charset="0"/>
                         <a:cs typeface="Arial" panose="020B0604020202020204" pitchFamily="34" charset="0"/>
@@ -5620,10 +6278,10 @@
       </p:sp>
       <p:pic>
         <p:nvPicPr>
-          <p:cNvPr id="3" name="图片 2">
-            <a:extLst>
-              <a:ext uri="{FF2B5EF4-FFF2-40B4-BE49-F238E27FC236}">
-                <a16:creationId xmlns:a16="http://schemas.microsoft.com/office/drawing/2014/main" id="{24BDDC98-9486-ABBD-04C3-98298C8A667D}"/>
+          <p:cNvPr id="4" name="图片 3" descr="图表, 条形图&#10;&#10;AI 生成的内容可能不正确。">
+            <a:extLst>
+              <a:ext uri="{FF2B5EF4-FFF2-40B4-BE49-F238E27FC236}">
+                <a16:creationId xmlns:a16="http://schemas.microsoft.com/office/drawing/2014/main" id="{E1692DA4-7ADD-A73D-4BEC-CFC7EA946DBF}"/>
               </a:ext>
             </a:extLst>
           </p:cNvPr>
@@ -5640,7 +6298,7 @@
         </p:blipFill>
         <p:spPr>
           <a:xfrm>
-            <a:off x="1033941" y="735954"/>
+            <a:off x="479719" y="735954"/>
             <a:ext cx="4716780" cy="5189220"/>
           </a:xfrm>
           <a:prstGeom prst="rect">
@@ -5661,7 +6319,7 @@
 </p:sld>
 </file>
 
-<file path=ppt/slides/slide6.xml><?xml version="1.0" encoding="utf-8"?>
+<file path=ppt/slides/slide8.xml><?xml version="1.0" encoding="utf-8"?>
 <p:sld xmlns:a="http://schemas.openxmlformats.org/drawingml/2006/main" xmlns:r="http://schemas.openxmlformats.org/officeDocument/2006/relationships" xmlns:p="http://schemas.openxmlformats.org/presentationml/2006/main">
   <p:cSld>
     <p:spTree>
@@ -5699,7 +6357,7 @@
         <p:spPr>
           <a:xfrm>
             <a:off x="479719" y="151179"/>
-            <a:ext cx="11219222" cy="1815882"/>
+            <a:ext cx="11219222" cy="1077218"/>
           </a:xfrm>
           <a:prstGeom prst="rect">
             <a:avLst/>
@@ -5721,77 +6379,10 @@
             </a:r>
           </a:p>
           <a:p>
-            <a:pPr marL="457200" indent="-457200">
-              <a:buAutoNum type="arabicPeriod"/>
-            </a:pPr>
-            <a:r>
-              <a:rPr lang="en-US" altLang="zh-CN" sz="2000" dirty="0">
-                <a:latin typeface="Arial" panose="020B0604020202020204" pitchFamily="34" charset="0"/>
-                <a:cs typeface="Arial" panose="020B0604020202020204" pitchFamily="34" charset="0"/>
-              </a:rPr>
-              <a:t>Extend dataset and include </a:t>
-            </a:r>
-            <a:r>
-              <a:rPr lang="en-US" altLang="zh-CN" sz="2000" dirty="0" err="1">
-                <a:latin typeface="Arial" panose="020B0604020202020204" pitchFamily="34" charset="0"/>
-                <a:cs typeface="Arial" panose="020B0604020202020204" pitchFamily="34" charset="0"/>
-              </a:rPr>
-              <a:t>HotpotQA</a:t>
-            </a:r>
-            <a:r>
-              <a:rPr lang="en-US" altLang="zh-CN" sz="2000" dirty="0">
-                <a:latin typeface="Arial" panose="020B0604020202020204" pitchFamily="34" charset="0"/>
-                <a:cs typeface="Arial" panose="020B0604020202020204" pitchFamily="34" charset="0"/>
-              </a:rPr>
-              <a:t> and </a:t>
-            </a:r>
-            <a:r>
-              <a:rPr lang="en-US" altLang="zh-CN" sz="2000" dirty="0" err="1">
-                <a:latin typeface="Arial" panose="020B0604020202020204" pitchFamily="34" charset="0"/>
-                <a:cs typeface="Arial" panose="020B0604020202020204" pitchFamily="34" charset="0"/>
-              </a:rPr>
-              <a:t>FreshQA</a:t>
-            </a:r>
-            <a:endParaRPr lang="en-US" altLang="zh-CN" sz="2000" dirty="0">
+            <a:endParaRPr lang="en-US" altLang="zh-CN" sz="3200" dirty="0">
               <a:latin typeface="Arial" panose="020B0604020202020204" pitchFamily="34" charset="0"/>
               <a:cs typeface="Arial" panose="020B0604020202020204" pitchFamily="34" charset="0"/>
             </a:endParaRPr>
-          </a:p>
-          <a:p>
-            <a:pPr marL="457200" indent="-457200">
-              <a:buAutoNum type="arabicPeriod"/>
-            </a:pPr>
-            <a:r>
-              <a:rPr lang="en-US" altLang="zh-CN" sz="2000" dirty="0">
-                <a:latin typeface="Arial" panose="020B0604020202020204" pitchFamily="34" charset="0"/>
-                <a:cs typeface="Arial" panose="020B0604020202020204" pitchFamily="34" charset="0"/>
-              </a:rPr>
-              <a:t>Find one newer dataset</a:t>
-            </a:r>
-          </a:p>
-          <a:p>
-            <a:pPr marL="457200" indent="-457200">
-              <a:buAutoNum type="arabicPeriod"/>
-            </a:pPr>
-            <a:r>
-              <a:rPr lang="en-US" altLang="zh-CN" sz="2000" dirty="0">
-                <a:latin typeface="Arial" panose="020B0604020202020204" pitchFamily="34" charset="0"/>
-                <a:cs typeface="Arial" panose="020B0604020202020204" pitchFamily="34" charset="0"/>
-              </a:rPr>
-              <a:t>Preparing for full-scale experiment</a:t>
-            </a:r>
-          </a:p>
-          <a:p>
-            <a:pPr marL="457200" indent="-457200">
-              <a:buAutoNum type="arabicPeriod"/>
-            </a:pPr>
-            <a:r>
-              <a:rPr lang="en-US" altLang="zh-CN" sz="2000" dirty="0">
-                <a:latin typeface="Arial" panose="020B0604020202020204" pitchFamily="34" charset="0"/>
-                <a:cs typeface="Arial" panose="020B0604020202020204" pitchFamily="34" charset="0"/>
-              </a:rPr>
-              <a:t>Run small-scale experiment on gpt-5</a:t>
-            </a:r>
           </a:p>
         </p:txBody>
       </p:sp>

</xml_diff>